<commit_message>
Fix slide titles to be complete sentences
- All 43 slide titles are now full sentences that convey key insights
- Longer titles use smaller font (22pt) to fit within template constraints
- Maintains concise, clear messaging while being grammatically complete

Co-Authored-By: Claude Opus 4.5 <noreply@anthropic.com>
</commit_message>
<xml_diff>
--- a/Claude-Code-Presentation.pptx
+++ b/Claude-Code-Presentation.pptx
@@ -5,55 +5,55 @@
     <p:sldMasterId id="2147483648" r:id="rId4"/>
   </p:sldMasterIdLst>
   <p:notesMasterIdLst>
-    <p:notesMasterId r:id="rId48"/>
+    <p:notesMasterId r:id="rId13"/>
   </p:notesMasterIdLst>
   <p:handoutMasterIdLst>
-    <p:handoutMasterId r:id="rId49"/>
+    <p:handoutMasterId r:id="rId14"/>
   </p:handoutMasterIdLst>
   <p:sldIdLst>
     <p:sldId id="343" r:id="rId5"/>
     <p:sldId id="344" r:id="rId6"/>
-    <p:sldId id="351" r:id="rId7"/>
-    <p:sldId id="352" r:id="rId8"/>
-    <p:sldId id="353" r:id="rId9"/>
-    <p:sldId id="354" r:id="rId10"/>
-    <p:sldId id="355" r:id="rId11"/>
-    <p:sldId id="356" r:id="rId12"/>
-    <p:sldId id="357" r:id="rId13"/>
-    <p:sldId id="358" r:id="rId14"/>
-    <p:sldId id="359" r:id="rId15"/>
-    <p:sldId id="360" r:id="rId16"/>
-    <p:sldId id="361" r:id="rId17"/>
-    <p:sldId id="362" r:id="rId18"/>
-    <p:sldId id="363" r:id="rId19"/>
-    <p:sldId id="364" r:id="rId20"/>
-    <p:sldId id="365" r:id="rId21"/>
-    <p:sldId id="366" r:id="rId22"/>
-    <p:sldId id="367" r:id="rId23"/>
-    <p:sldId id="368" r:id="rId24"/>
-    <p:sldId id="369" r:id="rId25"/>
-    <p:sldId id="370" r:id="rId26"/>
-    <p:sldId id="371" r:id="rId27"/>
-    <p:sldId id="372" r:id="rId28"/>
-    <p:sldId id="373" r:id="rId29"/>
-    <p:sldId id="374" r:id="rId30"/>
-    <p:sldId id="375" r:id="rId31"/>
-    <p:sldId id="376" r:id="rId32"/>
-    <p:sldId id="377" r:id="rId33"/>
-    <p:sldId id="378" r:id="rId34"/>
-    <p:sldId id="379" r:id="rId35"/>
-    <p:sldId id="380" r:id="rId36"/>
-    <p:sldId id="381" r:id="rId37"/>
-    <p:sldId id="382" r:id="rId38"/>
-    <p:sldId id="383" r:id="rId39"/>
-    <p:sldId id="384" r:id="rId40"/>
-    <p:sldId id="385" r:id="rId41"/>
-    <p:sldId id="386" r:id="rId42"/>
-    <p:sldId id="387" r:id="rId43"/>
-    <p:sldId id="388" r:id="rId44"/>
-    <p:sldId id="389" r:id="rId45"/>
-    <p:sldId id="390" r:id="rId46"/>
-    <p:sldId id="391" r:id="rId47"/>
+    <p:sldId id="351" r:id="rId20"/>
+    <p:sldId id="352" r:id="rId21"/>
+    <p:sldId id="353" r:id="rId22"/>
+    <p:sldId id="354" r:id="rId23"/>
+    <p:sldId id="355" r:id="rId24"/>
+    <p:sldId id="356" r:id="rId25"/>
+    <p:sldId id="357" r:id="rId26"/>
+    <p:sldId id="358" r:id="rId27"/>
+    <p:sldId id="359" r:id="rId28"/>
+    <p:sldId id="360" r:id="rId29"/>
+    <p:sldId id="361" r:id="rId30"/>
+    <p:sldId id="362" r:id="rId31"/>
+    <p:sldId id="363" r:id="rId32"/>
+    <p:sldId id="364" r:id="rId33"/>
+    <p:sldId id="365" r:id="rId34"/>
+    <p:sldId id="366" r:id="rId35"/>
+    <p:sldId id="367" r:id="rId36"/>
+    <p:sldId id="368" r:id="rId37"/>
+    <p:sldId id="369" r:id="rId38"/>
+    <p:sldId id="370" r:id="rId39"/>
+    <p:sldId id="371" r:id="rId40"/>
+    <p:sldId id="372" r:id="rId41"/>
+    <p:sldId id="373" r:id="rId42"/>
+    <p:sldId id="374" r:id="rId43"/>
+    <p:sldId id="375" r:id="rId44"/>
+    <p:sldId id="376" r:id="rId45"/>
+    <p:sldId id="377" r:id="rId46"/>
+    <p:sldId id="378" r:id="rId47"/>
+    <p:sldId id="379" r:id="rId48"/>
+    <p:sldId id="380" r:id="rId49"/>
+    <p:sldId id="381" r:id="rId50"/>
+    <p:sldId id="382" r:id="rId51"/>
+    <p:sldId id="383" r:id="rId52"/>
+    <p:sldId id="384" r:id="rId53"/>
+    <p:sldId id="385" r:id="rId54"/>
+    <p:sldId id="386" r:id="rId55"/>
+    <p:sldId id="387" r:id="rId56"/>
+    <p:sldId id="388" r:id="rId57"/>
+    <p:sldId id="389" r:id="rId58"/>
+    <p:sldId id="390" r:id="rId59"/>
+    <p:sldId id="391" r:id="rId60"/>
   </p:sldIdLst>
   <p:sldSz cx="12192000" cy="6858000"/>
   <p:notesSz cx="6858000" cy="9144000"/>
@@ -1712,7 +1712,7 @@
           </a:ln>
           <a:extLst>
             <a:ext uri="{C572A759-6A51-4108-AA02-DFA0A04FC94B}">
-              <ma14:wrappingTextBoxFlag xmlns="" xmlns:ma14="http://schemas.microsoft.com/office/mac/drawingml/2011/main" xmlns:a14="http://schemas.microsoft.com/office/drawing/2010/main" xmlns:m="http://schemas.openxmlformats.org/officeDocument/2006/math" val="1"/>
+              <ma14:wrappingTextBoxFlag xmlns:m="http://schemas.openxmlformats.org/officeDocument/2006/math" xmlns:a14="http://schemas.microsoft.com/office/drawing/2010/main" xmlns:ma14="http://schemas.microsoft.com/office/mac/drawingml/2011/main" xmlns="" val="1"/>
             </a:ext>
           </a:extLst>
         </p:spPr>
@@ -1751,7 +1751,7 @@
           </a:ln>
           <a:extLst>
             <a:ext uri="{C572A759-6A51-4108-AA02-DFA0A04FC94B}">
-              <ma14:wrappingTextBoxFlag xmlns="" xmlns:ma14="http://schemas.microsoft.com/office/mac/drawingml/2011/main" xmlns:a14="http://schemas.microsoft.com/office/drawing/2010/main" xmlns:m="http://schemas.openxmlformats.org/officeDocument/2006/math" val="1"/>
+              <ma14:wrappingTextBoxFlag xmlns:m="http://schemas.openxmlformats.org/officeDocument/2006/math" xmlns:a14="http://schemas.microsoft.com/office/drawing/2010/main" xmlns:ma14="http://schemas.microsoft.com/office/mac/drawingml/2011/main" xmlns="" val="1"/>
             </a:ext>
           </a:extLst>
         </p:spPr>
@@ -2768,7 +2768,7 @@
               <a:buNone/>
             </a:pPr>
             <a:r>
-              <a:rPr b="1"/>
+              <a:rPr b="1" sz="2800"/>
               <a:t>Claude Code: From Coding to Workflow Design</a:t>
             </a:r>
           </a:p>
@@ -2792,47 +2792,21 @@
         </p:nvSpPr>
         <p:spPr>
           <a:xfrm>
-            <a:off x="889000" y="3178098"/>
-            <a:ext cx="10414000" cy="1115122"/>
+            <a:off x="889000" y="2782606"/>
+            <a:ext cx="10414000" cy="793750"/>
           </a:xfrm>
         </p:spPr>
         <p:txBody>
-          <a:bodyPr>
-            <a:normAutofit fontScale="92500" lnSpcReduction="20000"/>
-          </a:bodyPr>
-          <a:lstStyle/>
-          <a:p>
-            <a:pPr marL="0" indent="0" algn="ctr">
+          <a:bodyPr/>
+          <a:lstStyle/>
+          <a:p>
+            <a:pPr algn="ctr" marL="0" indent="0">
               <a:buNone/>
             </a:pPr>
             <a:r>
-              <a:rPr lang="en-US" dirty="0"/>
-              <a:t>ChangHee Lee</a:t>
-            </a:r>
-          </a:p>
-          <a:p>
-            <a:pPr marL="0" indent="0" algn="ctr">
-              <a:buNone/>
-            </a:pPr>
-            <a:endParaRPr lang="en-US" dirty="0"/>
-          </a:p>
-          <a:p>
-            <a:pPr marL="0" indent="0" algn="ctr">
-              <a:buNone/>
-            </a:pPr>
-            <a:r>
-              <a:rPr lang="en-US" dirty="0"/>
-              <a:t>C</a:t>
-            </a:r>
-            <a:r>
-              <a:rPr dirty="0"/>
-              <a:t>omputational Team</a:t>
-            </a:r>
-            <a:r>
-              <a:rPr lang="en-US" dirty="0"/>
-              <a:t> 2026-01-14 (Wed)</a:t>
-            </a:r>
-            <a:endParaRPr dirty="0"/>
+              <a:t>Internal Computational Team
+January 2026</a:t>
+            </a:r>
           </a:p>
         </p:txBody>
       </p:sp>
@@ -2911,7 +2885,7 @@
 </file>
 
 <file path=ppt/slides/slide10.xml><?xml version="1.0" encoding="utf-8"?>
-<p:sld xmlns:a="http://schemas.openxmlformats.org/drawingml/2006/main" xmlns:r="http://schemas.openxmlformats.org/officeDocument/2006/relationships" xmlns:p="http://schemas.openxmlformats.org/presentationml/2006/main">
+<p:sld xmlns:a="http://schemas.openxmlformats.org/drawingml/2006/main" xmlns:p="http://schemas.openxmlformats.org/presentationml/2006/main" xmlns:r="http://schemas.openxmlformats.org/officeDocument/2006/relationships">
   <p:cSld>
     <p:spTree>
       <p:nvGrpSpPr>
@@ -2919,14 +2893,7 @@
         <p:cNvGrpSpPr/>
         <p:nvPr/>
       </p:nvGrpSpPr>
-      <p:grpSpPr>
-        <a:xfrm>
-          <a:off x="0" y="0"/>
-          <a:ext cx="0" cy="0"/>
-          <a:chOff x="0" y="0"/>
-          <a:chExt cx="0" cy="0"/>
-        </a:xfrm>
-      </p:grpSpPr>
+      <p:grpSpPr/>
       <p:sp>
         <p:nvSpPr>
           <p:cNvPr id="2" name="Title 1">
@@ -2952,8 +2919,8 @@
               <a:buNone/>
             </a:pPr>
             <a:r>
-              <a:rPr b="1"/>
-              <a:t>The Hard Context Limit</a:t>
+              <a:rPr b="1" sz="2200"/>
+              <a:t>Transformers have a hard context limit due to O(N²) complexity.</a:t>
             </a:r>
           </a:p>
         </p:txBody>
@@ -2995,7 +2962,7 @@
               <a:buChar char="•"/>
             </a:pPr>
             <a:r>
-              <a:t>Attention mechanism scales quadratically O(N²)</a:t>
+              <a:t>Attention mechanism scales quadratically with sequence length</a:t>
             </a:r>
           </a:p>
           <a:p>
@@ -3011,7 +2978,7 @@
               <a:buChar char="•"/>
             </a:pPr>
             <a:r>
-              <a:t>Everything must fit in this window</a:t>
+              <a:t>Everything the model knows about your task must fit in this window</a:t>
             </a:r>
           </a:p>
           <a:p>
@@ -3047,7 +3014,7 @@
           <a:p>
             <a:fld id="{86CB4B4D-7CA3-9044-876B-883B54F8677D}" type="slidenum">
               <a:rPr lang="en-US" smtClean="0"/>
-              <a:t>10</a:t>
+              <a:t>2</a:t>
             </a:fld>
             <a:endParaRPr lang="en-US"/>
           </a:p>
@@ -3062,7 +3029,7 @@
 </file>
 
 <file path=ppt/slides/slide11.xml><?xml version="1.0" encoding="utf-8"?>
-<p:sld xmlns:a="http://schemas.openxmlformats.org/drawingml/2006/main" xmlns:r="http://schemas.openxmlformats.org/officeDocument/2006/relationships" xmlns:p="http://schemas.openxmlformats.org/presentationml/2006/main">
+<p:sld xmlns:a="http://schemas.openxmlformats.org/drawingml/2006/main" xmlns:p="http://schemas.openxmlformats.org/presentationml/2006/main" xmlns:r="http://schemas.openxmlformats.org/officeDocument/2006/relationships">
   <p:cSld>
     <p:spTree>
       <p:nvGrpSpPr>
@@ -3070,14 +3037,7 @@
         <p:cNvGrpSpPr/>
         <p:nvPr/>
       </p:nvGrpSpPr>
-      <p:grpSpPr>
-        <a:xfrm>
-          <a:off x="0" y="0"/>
-          <a:ext cx="0" cy="0"/>
-          <a:chOff x="0" y="0"/>
-          <a:chExt cx="0" cy="0"/>
-        </a:xfrm>
-      </p:grpSpPr>
+      <p:grpSpPr/>
       <p:sp>
         <p:nvSpPr>
           <p:cNvPr id="2" name="Title 1">
@@ -3103,8 +3063,8 @@
               <a:buNone/>
             </a:pPr>
             <a:r>
-              <a:rPr b="1"/>
-              <a:t>Context Engineering Is Fundamental</a:t>
+              <a:rPr b="1" sz="2400"/>
+              <a:t>Context engineering is the fundamental skill for agent work.</a:t>
             </a:r>
           </a:p>
         </p:txBody>
@@ -3154,7 +3114,7 @@
               <a:buChar char="•"/>
             </a:pPr>
             <a:r>
-              <a:t>File-based planning: External markdown preserves info</a:t>
+              <a:t>File-based planning: External markdown preserves info across sessions</a:t>
             </a:r>
           </a:p>
           <a:p>
@@ -3170,7 +3130,7 @@
               <a:buChar char="•"/>
             </a:pPr>
             <a:r>
-              <a:t>Pre-session artifacts: Research → implementation sessions</a:t>
+              <a:t>Pre-session artifacts: Research sessions → implementation sessions</a:t>
             </a:r>
           </a:p>
         </p:txBody>
@@ -3198,7 +3158,7 @@
           <a:p>
             <a:fld id="{86CB4B4D-7CA3-9044-876B-883B54F8677D}" type="slidenum">
               <a:rPr lang="en-US" smtClean="0"/>
-              <a:t>11</a:t>
+              <a:t>2</a:t>
             </a:fld>
             <a:endParaRPr lang="en-US"/>
           </a:p>
@@ -3213,7 +3173,7 @@
 </file>
 
 <file path=ppt/slides/slide12.xml><?xml version="1.0" encoding="utf-8"?>
-<p:sld xmlns:a="http://schemas.openxmlformats.org/drawingml/2006/main" xmlns:r="http://schemas.openxmlformats.org/officeDocument/2006/relationships" xmlns:p="http://schemas.openxmlformats.org/presentationml/2006/main">
+<p:sld xmlns:a="http://schemas.openxmlformats.org/drawingml/2006/main" xmlns:p="http://schemas.openxmlformats.org/presentationml/2006/main" xmlns:r="http://schemas.openxmlformats.org/officeDocument/2006/relationships">
   <p:cSld>
     <p:spTree>
       <p:nvGrpSpPr>
@@ -3221,14 +3181,7 @@
         <p:cNvGrpSpPr/>
         <p:nvPr/>
       </p:nvGrpSpPr>
-      <p:grpSpPr>
-        <a:xfrm>
-          <a:off x="0" y="0"/>
-          <a:ext cx="0" cy="0"/>
-          <a:chOff x="0" y="0"/>
-          <a:chExt cx="0" cy="0"/>
-        </a:xfrm>
-      </p:grpSpPr>
+      <p:grpSpPr/>
       <p:sp>
         <p:nvSpPr>
           <p:cNvPr id="2" name="Title 1">
@@ -3254,8 +3207,8 @@
               <a:buNone/>
             </a:pPr>
             <a:r>
-              <a:rPr b="1"/>
-              <a:t>Monitor Context with /status</a:t>
+              <a:rPr b="1" sz="2200"/>
+              <a:t>The /status command lets you monitor context usage in real-time.</a:t>
             </a:r>
           </a:p>
         </p:txBody>
@@ -3349,7 +3302,7 @@
           <a:p>
             <a:fld id="{86CB4B4D-7CA3-9044-876B-883B54F8677D}" type="slidenum">
               <a:rPr lang="en-US" smtClean="0"/>
-              <a:t>12</a:t>
+              <a:t>2</a:t>
             </a:fld>
             <a:endParaRPr lang="en-US"/>
           </a:p>
@@ -3364,7 +3317,7 @@
 </file>
 
 <file path=ppt/slides/slide13.xml><?xml version="1.0" encoding="utf-8"?>
-<p:sld xmlns:a="http://schemas.openxmlformats.org/drawingml/2006/main" xmlns:r="http://schemas.openxmlformats.org/officeDocument/2006/relationships" xmlns:p="http://schemas.openxmlformats.org/presentationml/2006/main">
+<p:sld xmlns:a="http://schemas.openxmlformats.org/drawingml/2006/main" xmlns:p="http://schemas.openxmlformats.org/presentationml/2006/main" xmlns:r="http://schemas.openxmlformats.org/officeDocument/2006/relationships">
   <p:cSld>
     <p:spTree>
       <p:nvGrpSpPr>
@@ -3372,14 +3325,7 @@
         <p:cNvGrpSpPr/>
         <p:nvPr/>
       </p:nvGrpSpPr>
-      <p:grpSpPr>
-        <a:xfrm>
-          <a:off x="0" y="0"/>
-          <a:ext cx="0" cy="0"/>
-          <a:chOff x="0" y="0"/>
-          <a:chExt cx="0" cy="0"/>
-        </a:xfrm>
-      </p:grpSpPr>
+      <p:grpSpPr/>
       <p:sp>
         <p:nvSpPr>
           <p:cNvPr id="2" name="Title 1">
@@ -3405,8 +3351,8 @@
               <a:buNone/>
             </a:pPr>
             <a:r>
-              <a:rPr b="1"/>
-              <a:t>Subagents: Fresh Context Windows</a:t>
+              <a:rPr b="1" sz="2400"/>
+              <a:t>Subagents spawn fresh context windows for parallel tasks.</a:t>
             </a:r>
           </a:p>
         </p:txBody>
@@ -3500,7 +3446,7 @@
           <a:p>
             <a:fld id="{86CB4B4D-7CA3-9044-876B-883B54F8677D}" type="slidenum">
               <a:rPr lang="en-US" smtClean="0"/>
-              <a:t>13</a:t>
+              <a:t>2</a:t>
             </a:fld>
             <a:endParaRPr lang="en-US"/>
           </a:p>
@@ -3515,7 +3461,7 @@
 </file>
 
 <file path=ppt/slides/slide14.xml><?xml version="1.0" encoding="utf-8"?>
-<p:sld xmlns:a="http://schemas.openxmlformats.org/drawingml/2006/main" xmlns:r="http://schemas.openxmlformats.org/officeDocument/2006/relationships" xmlns:p="http://schemas.openxmlformats.org/presentationml/2006/main">
+<p:sld xmlns:a="http://schemas.openxmlformats.org/drawingml/2006/main" xmlns:p="http://schemas.openxmlformats.org/presentationml/2006/main" xmlns:r="http://schemas.openxmlformats.org/officeDocument/2006/relationships">
   <p:cSld>
     <p:spTree>
       <p:nvGrpSpPr>
@@ -3523,14 +3469,7 @@
         <p:cNvGrpSpPr/>
         <p:nvPr/>
       </p:nvGrpSpPr>
-      <p:grpSpPr>
-        <a:xfrm>
-          <a:off x="0" y="0"/>
-          <a:ext cx="0" cy="0"/>
-          <a:chOff x="0" y="0"/>
-          <a:chExt cx="0" cy="0"/>
-        </a:xfrm>
-      </p:grpSpPr>
+      <p:grpSpPr/>
       <p:sp>
         <p:nvSpPr>
           <p:cNvPr id="2" name="Title 1">
@@ -3556,8 +3495,8 @@
               <a:buNone/>
             </a:pPr>
             <a:r>
-              <a:rPr b="1"/>
-              <a:t>Taxonomy of Agentic Patterns</a:t>
+              <a:rPr b="1" sz="2400"/>
+              <a:t>A taxonomy of agentic patterns has emerged from practice.</a:t>
             </a:r>
           </a:p>
         </p:txBody>
@@ -3651,7 +3590,7 @@
           <a:p>
             <a:fld id="{86CB4B4D-7CA3-9044-876B-883B54F8677D}" type="slidenum">
               <a:rPr lang="en-US" smtClean="0"/>
-              <a:t>14</a:t>
+              <a:t>2</a:t>
             </a:fld>
             <a:endParaRPr lang="en-US"/>
           </a:p>
@@ -3666,7 +3605,7 @@
 </file>
 
 <file path=ppt/slides/slide15.xml><?xml version="1.0" encoding="utf-8"?>
-<p:sld xmlns:a="http://schemas.openxmlformats.org/drawingml/2006/main" xmlns:r="http://schemas.openxmlformats.org/officeDocument/2006/relationships" xmlns:p="http://schemas.openxmlformats.org/presentationml/2006/main">
+<p:sld xmlns:a="http://schemas.openxmlformats.org/drawingml/2006/main" xmlns:p="http://schemas.openxmlformats.org/presentationml/2006/main" xmlns:r="http://schemas.openxmlformats.org/officeDocument/2006/relationships">
   <p:cSld>
     <p:spTree>
       <p:nvGrpSpPr>
@@ -3674,14 +3613,7 @@
         <p:cNvGrpSpPr/>
         <p:nvPr/>
       </p:nvGrpSpPr>
-      <p:grpSpPr>
-        <a:xfrm>
-          <a:off x="0" y="0"/>
-          <a:ext cx="0" cy="0"/>
-          <a:chOff x="0" y="0"/>
-          <a:chExt cx="0" cy="0"/>
-        </a:xfrm>
-      </p:grpSpPr>
+      <p:grpSpPr/>
       <p:sp>
         <p:nvSpPr>
           <p:cNvPr id="2" name="Title 1">
@@ -3707,8 +3639,8 @@
               <a:buNone/>
             </a:pPr>
             <a:r>
-              <a:rPr b="1"/>
-              <a:t>Skills: Markdown Instructions On-Demand</a:t>
+              <a:rPr b="1" sz="2400"/>
+              <a:t>Skills are markdown files that Claude loads on demand.</a:t>
             </a:r>
           </a:p>
         </p:txBody>
@@ -3802,7 +3734,7 @@
           <a:p>
             <a:fld id="{86CB4B4D-7CA3-9044-876B-883B54F8677D}" type="slidenum">
               <a:rPr lang="en-US" smtClean="0"/>
-              <a:t>15</a:t>
+              <a:t>2</a:t>
             </a:fld>
             <a:endParaRPr lang="en-US"/>
           </a:p>
@@ -3817,7 +3749,7 @@
 </file>
 
 <file path=ppt/slides/slide16.xml><?xml version="1.0" encoding="utf-8"?>
-<p:sld xmlns:a="http://schemas.openxmlformats.org/drawingml/2006/main" xmlns:r="http://schemas.openxmlformats.org/officeDocument/2006/relationships" xmlns:p="http://schemas.openxmlformats.org/presentationml/2006/main">
+<p:sld xmlns:a="http://schemas.openxmlformats.org/drawingml/2006/main" xmlns:p="http://schemas.openxmlformats.org/presentationml/2006/main" xmlns:r="http://schemas.openxmlformats.org/officeDocument/2006/relationships">
   <p:cSld>
     <p:spTree>
       <p:nvGrpSpPr>
@@ -3825,14 +3757,7 @@
         <p:cNvGrpSpPr/>
         <p:nvPr/>
       </p:nvGrpSpPr>
-      <p:grpSpPr>
-        <a:xfrm>
-          <a:off x="0" y="0"/>
-          <a:ext cx="0" cy="0"/>
-          <a:chOff x="0" y="0"/>
-          <a:chExt cx="0" cy="0"/>
-        </a:xfrm>
-      </p:grpSpPr>
+      <p:grpSpPr/>
       <p:sp>
         <p:nvSpPr>
           <p:cNvPr id="2" name="Title 1">
@@ -3858,8 +3783,8 @@
               <a:buNone/>
             </a:pPr>
             <a:r>
-              <a:rPr b="1"/>
-              <a:t>140+ Scientific Skills Available</a:t>
+              <a:rPr b="1" sz="2200"/>
+              <a:t>140+ scientific skills cover databases, packages, and integrations.</a:t>
             </a:r>
           </a:p>
         </p:txBody>
@@ -3925,7 +3850,7 @@
               <a:buChar char="•"/>
             </a:pPr>
             <a:r>
-              <a:t>Categories: Bioinformatics, Cheminformatics, ML/AI</a:t>
+              <a:t>Categories: Bioinformatics, Cheminformatics, Clinical Research, ML/AI</a:t>
             </a:r>
           </a:p>
         </p:txBody>
@@ -3953,7 +3878,7 @@
           <a:p>
             <a:fld id="{86CB4B4D-7CA3-9044-876B-883B54F8677D}" type="slidenum">
               <a:rPr lang="en-US" smtClean="0"/>
-              <a:t>16</a:t>
+              <a:t>2</a:t>
             </a:fld>
             <a:endParaRPr lang="en-US"/>
           </a:p>
@@ -3968,7 +3893,7 @@
 </file>
 
 <file path=ppt/slides/slide17.xml><?xml version="1.0" encoding="utf-8"?>
-<p:sld xmlns:a="http://schemas.openxmlformats.org/drawingml/2006/main" xmlns:r="http://schemas.openxmlformats.org/officeDocument/2006/relationships" xmlns:p="http://schemas.openxmlformats.org/presentationml/2006/main">
+<p:sld xmlns:a="http://schemas.openxmlformats.org/drawingml/2006/main" xmlns:p="http://schemas.openxmlformats.org/presentationml/2006/main" xmlns:r="http://schemas.openxmlformats.org/officeDocument/2006/relationships">
   <p:cSld>
     <p:spTree>
       <p:nvGrpSpPr>
@@ -3976,14 +3901,7 @@
         <p:cNvGrpSpPr/>
         <p:nvPr/>
       </p:nvGrpSpPr>
-      <p:grpSpPr>
-        <a:xfrm>
-          <a:off x="0" y="0"/>
-          <a:ext cx="0" cy="0"/>
-          <a:chOff x="0" y="0"/>
-          <a:chExt cx="0" cy="0"/>
-        </a:xfrm>
-      </p:grpSpPr>
+      <p:grpSpPr/>
       <p:sp>
         <p:nvSpPr>
           <p:cNvPr id="2" name="Title 1">
@@ -4009,8 +3927,8 @@
               <a:buNone/>
             </a:pPr>
             <a:r>
-              <a:rPr b="1"/>
-              <a:t>MCP: Convenience vs Context Trade-off</a:t>
+              <a:rPr b="1" sz="2200"/>
+              <a:t>MCP servers can waste 7-9% of context window on unused tools.</a:t>
             </a:r>
           </a:p>
         </p:txBody>
@@ -4076,7 +3994,7 @@
               <a:buChar char="•"/>
             </a:pPr>
             <a:r>
-              <a:t>7-9% context window overhead for unused tools</a:t>
+              <a:t>Trade-off: Convenience vs. context efficiency</a:t>
             </a:r>
           </a:p>
         </p:txBody>
@@ -4104,7 +4022,7 @@
           <a:p>
             <a:fld id="{86CB4B4D-7CA3-9044-876B-883B54F8677D}" type="slidenum">
               <a:rPr lang="en-US" smtClean="0"/>
-              <a:t>17</a:t>
+              <a:t>2</a:t>
             </a:fld>
             <a:endParaRPr lang="en-US"/>
           </a:p>
@@ -4119,7 +4037,7 @@
 </file>
 
 <file path=ppt/slides/slide18.xml><?xml version="1.0" encoding="utf-8"?>
-<p:sld xmlns:a="http://schemas.openxmlformats.org/drawingml/2006/main" xmlns:r="http://schemas.openxmlformats.org/officeDocument/2006/relationships" xmlns:p="http://schemas.openxmlformats.org/presentationml/2006/main">
+<p:sld xmlns:a="http://schemas.openxmlformats.org/drawingml/2006/main" xmlns:p="http://schemas.openxmlformats.org/presentationml/2006/main" xmlns:r="http://schemas.openxmlformats.org/officeDocument/2006/relationships">
   <p:cSld>
     <p:spTree>
       <p:nvGrpSpPr>
@@ -4127,14 +4045,7 @@
         <p:cNvGrpSpPr/>
         <p:nvPr/>
       </p:nvGrpSpPr>
-      <p:grpSpPr>
-        <a:xfrm>
-          <a:off x="0" y="0"/>
-          <a:ext cx="0" cy="0"/>
-          <a:chOff x="0" y="0"/>
-          <a:chExt cx="0" cy="0"/>
-        </a:xfrm>
-      </p:grpSpPr>
+      <p:grpSpPr/>
       <p:sp>
         <p:nvSpPr>
           <p:cNvPr id="2" name="Title 1">
@@ -4160,8 +4071,8 @@
               <a:buNone/>
             </a:pPr>
             <a:r>
-              <a:rPr b="1"/>
-              <a:t>Git Worktree: Parallel Sessions</a:t>
+              <a:rPr b="1" sz="2200"/>
+              <a:t>Git worktree enables running multiple Claude sessions in parallel.</a:t>
             </a:r>
           </a:p>
         </p:txBody>
@@ -4227,7 +4138,7 @@
               <a:buChar char="•"/>
             </a:pPr>
             <a:r>
-              <a:t>Boris Cherny runs 5 Claudes in parallel!</a:t>
+              <a:t>Boris Cherny (Claude Code creator) runs 5 Claudes in parallel!</a:t>
             </a:r>
           </a:p>
         </p:txBody>
@@ -4255,7 +4166,7 @@
           <a:p>
             <a:fld id="{86CB4B4D-7CA3-9044-876B-883B54F8677D}" type="slidenum">
               <a:rPr lang="en-US" smtClean="0"/>
-              <a:t>18</a:t>
+              <a:t>2</a:t>
             </a:fld>
             <a:endParaRPr lang="en-US"/>
           </a:p>
@@ -4270,7 +4181,7 @@
 </file>
 
 <file path=ppt/slides/slide19.xml><?xml version="1.0" encoding="utf-8"?>
-<p:sld xmlns:a="http://schemas.openxmlformats.org/drawingml/2006/main" xmlns:r="http://schemas.openxmlformats.org/officeDocument/2006/relationships" xmlns:p="http://schemas.openxmlformats.org/presentationml/2006/main">
+<p:sld xmlns:a="http://schemas.openxmlformats.org/drawingml/2006/main" xmlns:p="http://schemas.openxmlformats.org/presentationml/2006/main" xmlns:r="http://schemas.openxmlformats.org/officeDocument/2006/relationships">
   <p:cSld>
     <p:spTree>
       <p:nvGrpSpPr>
@@ -4278,14 +4189,7 @@
         <p:cNvGrpSpPr/>
         <p:nvPr/>
       </p:nvGrpSpPr>
-      <p:grpSpPr>
-        <a:xfrm>
-          <a:off x="0" y="0"/>
-          <a:ext cx="0" cy="0"/>
-          <a:chOff x="0" y="0"/>
-          <a:chExt cx="0" cy="0"/>
-        </a:xfrm>
-      </p:grpSpPr>
+      <p:grpSpPr/>
       <p:sp>
         <p:nvSpPr>
           <p:cNvPr id="2" name="Title 1">
@@ -4311,8 +4215,8 @@
               <a:buNone/>
             </a:pPr>
             <a:r>
-              <a:rPr b="1"/>
-              <a:t>Three Pillars of Agent Efficiency</a:t>
+              <a:rPr b="1" sz="2200"/>
+              <a:t>Workflow, context, and parallelization are the efficiency pillars.</a:t>
             </a:r>
           </a:p>
         </p:txBody>
@@ -4378,7 +4282,7 @@
               <a:buChar char="•"/>
             </a:pPr>
             <a:r>
-              <a:t>Trust the workflow, then multiply it</a:t>
+              <a:t>Once you trust the workflow, multiplying it becomes obvious</a:t>
             </a:r>
           </a:p>
         </p:txBody>
@@ -4406,7 +4310,7 @@
           <a:p>
             <a:fld id="{86CB4B4D-7CA3-9044-876B-883B54F8677D}" type="slidenum">
               <a:rPr lang="en-US" smtClean="0"/>
-              <a:t>19</a:t>
+              <a:t>2</a:t>
             </a:fld>
             <a:endParaRPr lang="en-US"/>
           </a:p>
@@ -4462,8 +4366,8 @@
               <a:buNone/>
             </a:pPr>
             <a:r>
-              <a:rPr b="1"/>
-              <a:t>The Old vs New Mental Model</a:t>
+              <a:rPr b="1" sz="2400"/>
+              <a:t>We're stuck in an old mental model of development.</a:t>
             </a:r>
           </a:p>
         </p:txBody>
@@ -4594,7 +4498,7 @@
 </file>
 
 <file path=ppt/slides/slide20.xml><?xml version="1.0" encoding="utf-8"?>
-<p:sld xmlns:a="http://schemas.openxmlformats.org/drawingml/2006/main" xmlns:r="http://schemas.openxmlformats.org/officeDocument/2006/relationships" xmlns:p="http://schemas.openxmlformats.org/presentationml/2006/main">
+<p:sld xmlns:a="http://schemas.openxmlformats.org/drawingml/2006/main" xmlns:p="http://schemas.openxmlformats.org/presentationml/2006/main" xmlns:r="http://schemas.openxmlformats.org/officeDocument/2006/relationships">
   <p:cSld>
     <p:spTree>
       <p:nvGrpSpPr>
@@ -4602,14 +4506,7 @@
         <p:cNvGrpSpPr/>
         <p:nvPr/>
       </p:nvGrpSpPr>
-      <p:grpSpPr>
-        <a:xfrm>
-          <a:off x="0" y="0"/>
-          <a:ext cx="0" cy="0"/>
-          <a:chOff x="0" y="0"/>
-          <a:chExt cx="0" cy="0"/>
-        </a:xfrm>
-      </p:grpSpPr>
+      <p:grpSpPr/>
       <p:sp>
         <p:nvSpPr>
           <p:cNvPr id="2" name="Title 1">
@@ -4635,8 +4532,8 @@
               <a:buNone/>
             </a:pPr>
             <a:r>
-              <a:rPr b="1"/>
-              <a:t>Getting Started: One Command</a:t>
+              <a:rPr b="1" sz="2400"/>
+              <a:t>Getting started requires one npm install and authentication.</a:t>
             </a:r>
           </a:p>
         </p:txBody>
@@ -4702,7 +4599,7 @@
               <a:buChar char="•"/>
             </a:pPr>
             <a:r>
-              <a:t>First run: authenticate, create ~/.claude/, run /init</a:t>
+              <a:t>First run: authenticate, create ~/.claude/, optionally run /init</a:t>
             </a:r>
           </a:p>
         </p:txBody>
@@ -4730,7 +4627,7 @@
           <a:p>
             <a:fld id="{86CB4B4D-7CA3-9044-876B-883B54F8677D}" type="slidenum">
               <a:rPr lang="en-US" smtClean="0"/>
-              <a:t>20</a:t>
+              <a:t>2</a:t>
             </a:fld>
             <a:endParaRPr lang="en-US"/>
           </a:p>
@@ -4745,7 +4642,7 @@
 </file>
 
 <file path=ppt/slides/slide21.xml><?xml version="1.0" encoding="utf-8"?>
-<p:sld xmlns:a="http://schemas.openxmlformats.org/drawingml/2006/main" xmlns:r="http://schemas.openxmlformats.org/officeDocument/2006/relationships" xmlns:p="http://schemas.openxmlformats.org/presentationml/2006/main">
+<p:sld xmlns:a="http://schemas.openxmlformats.org/drawingml/2006/main" xmlns:p="http://schemas.openxmlformats.org/presentationml/2006/main" xmlns:r="http://schemas.openxmlformats.org/officeDocument/2006/relationships">
   <p:cSld>
     <p:spTree>
       <p:nvGrpSpPr>
@@ -4753,14 +4650,7 @@
         <p:cNvGrpSpPr/>
         <p:nvPr/>
       </p:nvGrpSpPr>
-      <p:grpSpPr>
-        <a:xfrm>
-          <a:off x="0" y="0"/>
-          <a:ext cx="0" cy="0"/>
-          <a:chOff x="0" y="0"/>
-          <a:chExt cx="0" cy="0"/>
-        </a:xfrm>
-      </p:grpSpPr>
+      <p:grpSpPr/>
       <p:sp>
         <p:nvSpPr>
           <p:cNvPr id="2" name="Title 1">
@@ -4786,8 +4676,8 @@
               <a:buNone/>
             </a:pPr>
             <a:r>
-              <a:rPr b="1"/>
-              <a:t>Subscription Plans: $20-$200/month</a:t>
+              <a:rPr b="1" sz="2400"/>
+              <a:t>Subscription plans range from $20 to $200/month.</a:t>
             </a:r>
           </a:p>
         </p:txBody>
@@ -4881,7 +4771,7 @@
           <a:p>
             <a:fld id="{86CB4B4D-7CA3-9044-876B-883B54F8677D}" type="slidenum">
               <a:rPr lang="en-US" smtClean="0"/>
-              <a:t>21</a:t>
+              <a:t>2</a:t>
             </a:fld>
             <a:endParaRPr lang="en-US"/>
           </a:p>
@@ -4896,7 +4786,7 @@
 </file>
 
 <file path=ppt/slides/slide22.xml><?xml version="1.0" encoding="utf-8"?>
-<p:sld xmlns:a="http://schemas.openxmlformats.org/drawingml/2006/main" xmlns:r="http://schemas.openxmlformats.org/officeDocument/2006/relationships" xmlns:p="http://schemas.openxmlformats.org/presentationml/2006/main">
+<p:sld xmlns:a="http://schemas.openxmlformats.org/drawingml/2006/main" xmlns:p="http://schemas.openxmlformats.org/presentationml/2006/main" xmlns:r="http://schemas.openxmlformats.org/officeDocument/2006/relationships">
   <p:cSld>
     <p:spTree>
       <p:nvGrpSpPr>
@@ -4904,14 +4794,7 @@
         <p:cNvGrpSpPr/>
         <p:nvPr/>
       </p:nvGrpSpPr>
-      <p:grpSpPr>
-        <a:xfrm>
-          <a:off x="0" y="0"/>
-          <a:ext cx="0" cy="0"/>
-          <a:chOff x="0" y="0"/>
-          <a:chExt cx="0" cy="0"/>
-        </a:xfrm>
-      </p:grpSpPr>
+      <p:grpSpPr/>
       <p:sp>
         <p:nvSpPr>
           <p:cNvPr id="2" name="Title 1">
@@ -4937,8 +4820,8 @@
               <a:buNone/>
             </a:pPr>
             <a:r>
-              <a:rPr b="1"/>
-              <a:t>Statusline: Real-time Monitoring</a:t>
+              <a:rPr b="1" sz="2400"/>
+              <a:t>A customizable statusline displays model, cost, and tokens.</a:t>
             </a:r>
           </a:p>
         </p:txBody>
@@ -5004,7 +4887,7 @@
               <a:buChar char="•"/>
             </a:pPr>
             <a:r>
-              <a:t>Setup: /statusline show model and context usage</a:t>
+              <a:t>Setup: /statusline show the model name and context usage percentage</a:t>
             </a:r>
           </a:p>
         </p:txBody>
@@ -5032,7 +4915,7 @@
           <a:p>
             <a:fld id="{86CB4B4D-7CA3-9044-876B-883B54F8677D}" type="slidenum">
               <a:rPr lang="en-US" smtClean="0"/>
-              <a:t>22</a:t>
+              <a:t>2</a:t>
             </a:fld>
             <a:endParaRPr lang="en-US"/>
           </a:p>
@@ -5047,7 +4930,7 @@
 </file>
 
 <file path=ppt/slides/slide23.xml><?xml version="1.0" encoding="utf-8"?>
-<p:sld xmlns:a="http://schemas.openxmlformats.org/drawingml/2006/main" xmlns:r="http://schemas.openxmlformats.org/officeDocument/2006/relationships" xmlns:p="http://schemas.openxmlformats.org/presentationml/2006/main">
+<p:sld xmlns:a="http://schemas.openxmlformats.org/drawingml/2006/main" xmlns:p="http://schemas.openxmlformats.org/presentationml/2006/main" xmlns:r="http://schemas.openxmlformats.org/officeDocument/2006/relationships">
   <p:cSld>
     <p:spTree>
       <p:nvGrpSpPr>
@@ -5055,14 +4938,7 @@
         <p:cNvGrpSpPr/>
         <p:nvPr/>
       </p:nvGrpSpPr>
-      <p:grpSpPr>
-        <a:xfrm>
-          <a:off x="0" y="0"/>
-          <a:ext cx="0" cy="0"/>
-          <a:chOff x="0" y="0"/>
-          <a:chExt cx="0" cy="0"/>
-        </a:xfrm>
-      </p:grpSpPr>
+      <p:grpSpPr/>
       <p:sp>
         <p:nvSpPr>
           <p:cNvPr id="2" name="Title 1">
@@ -5088,8 +4964,8 @@
               <a:buNone/>
             </a:pPr>
             <a:r>
-              <a:rPr b="1"/>
-              <a:t>/status Command: Session Dashboard</a:t>
+              <a:rPr b="1" sz="2400"/>
+              <a:t>The /status command shows session info, config, and usage.</a:t>
             </a:r>
           </a:p>
         </p:txBody>
@@ -5155,7 +5031,7 @@
               <a:buChar char="•"/>
             </a:pPr>
             <a:r>
-              <a:t>Demo: Switch between tabs with Tab key</a:t>
+              <a:t>Demo switching between tabs with Tab key</a:t>
             </a:r>
           </a:p>
         </p:txBody>
@@ -5183,7 +5059,7 @@
           <a:p>
             <a:fld id="{86CB4B4D-7CA3-9044-876B-883B54F8677D}" type="slidenum">
               <a:rPr lang="en-US" smtClean="0"/>
-              <a:t>23</a:t>
+              <a:t>2</a:t>
             </a:fld>
             <a:endParaRPr lang="en-US"/>
           </a:p>
@@ -5198,7 +5074,7 @@
 </file>
 
 <file path=ppt/slides/slide24.xml><?xml version="1.0" encoding="utf-8"?>
-<p:sld xmlns:a="http://schemas.openxmlformats.org/drawingml/2006/main" xmlns:r="http://schemas.openxmlformats.org/officeDocument/2006/relationships" xmlns:p="http://schemas.openxmlformats.org/presentationml/2006/main">
+<p:sld xmlns:a="http://schemas.openxmlformats.org/drawingml/2006/main" xmlns:p="http://schemas.openxmlformats.org/presentationml/2006/main" xmlns:r="http://schemas.openxmlformats.org/officeDocument/2006/relationships">
   <p:cSld>
     <p:spTree>
       <p:nvGrpSpPr>
@@ -5206,14 +5082,7 @@
         <p:cNvGrpSpPr/>
         <p:nvPr/>
       </p:nvGrpSpPr>
-      <p:grpSpPr>
-        <a:xfrm>
-          <a:off x="0" y="0"/>
-          <a:ext cx="0" cy="0"/>
-          <a:chOff x="0" y="0"/>
-          <a:chExt cx="0" cy="0"/>
-        </a:xfrm>
-      </p:grpSpPr>
+      <p:grpSpPr/>
       <p:sp>
         <p:nvSpPr>
           <p:cNvPr id="2" name="Title 1">
@@ -5239,8 +5108,8 @@
               <a:buNone/>
             </a:pPr>
             <a:r>
-              <a:rPr b="1"/>
-              <a:t>CLAUDE.md: Project-Specific Context</a:t>
+              <a:rPr b="1" sz="2400"/>
+              <a:t>CLAUDE.md gives Claude persistent project-specific context.</a:t>
             </a:r>
           </a:p>
         </p:txBody>
@@ -5286,7 +5155,7 @@
             </a:r>
           </a:p>
           <a:p>
-            <a:pPr marL="731520" lvl="1" indent="-182880" algn="l">
+            <a:pPr lvl="1" marL="731520" indent="-182880" algn="l">
               <a:buChar char="•"/>
             </a:pPr>
             <a:r>
@@ -5294,7 +5163,7 @@
             </a:r>
           </a:p>
           <a:p>
-            <a:pPr marL="731520" lvl="1" indent="-182880" algn="l">
+            <a:pPr lvl="1" marL="731520" indent="-182880" algn="l">
               <a:buChar char="•"/>
             </a:pPr>
             <a:r>
@@ -5334,7 +5203,7 @@
           <a:p>
             <a:fld id="{86CB4B4D-7CA3-9044-876B-883B54F8677D}" type="slidenum">
               <a:rPr lang="en-US" smtClean="0"/>
-              <a:t>24</a:t>
+              <a:t>2</a:t>
             </a:fld>
             <a:endParaRPr lang="en-US"/>
           </a:p>
@@ -5349,7 +5218,7 @@
 </file>
 
 <file path=ppt/slides/slide25.xml><?xml version="1.0" encoding="utf-8"?>
-<p:sld xmlns:a="http://schemas.openxmlformats.org/drawingml/2006/main" xmlns:r="http://schemas.openxmlformats.org/officeDocument/2006/relationships" xmlns:p="http://schemas.openxmlformats.org/presentationml/2006/main">
+<p:sld xmlns:a="http://schemas.openxmlformats.org/drawingml/2006/main" xmlns:p="http://schemas.openxmlformats.org/presentationml/2006/main" xmlns:r="http://schemas.openxmlformats.org/officeDocument/2006/relationships">
   <p:cSld>
     <p:spTree>
       <p:nvGrpSpPr>
@@ -5357,14 +5226,7 @@
         <p:cNvGrpSpPr/>
         <p:nvPr/>
       </p:nvGrpSpPr>
-      <p:grpSpPr>
-        <a:xfrm>
-          <a:off x="0" y="0"/>
-          <a:ext cx="0" cy="0"/>
-          <a:chOff x="0" y="0"/>
-          <a:chExt cx="0" cy="0"/>
-        </a:xfrm>
-      </p:grpSpPr>
+      <p:grpSpPr/>
       <p:sp>
         <p:nvSpPr>
           <p:cNvPr id="2" name="Title 1">
@@ -5390,8 +5252,8 @@
               <a:buNone/>
             </a:pPr>
             <a:r>
-              <a:rPr b="1"/>
-              <a:t>Four Permission Modes</a:t>
+              <a:rPr b="1" sz="2400"/>
+              <a:t>Four permission modes balance control and convenience.</a:t>
             </a:r>
           </a:p>
         </p:txBody>
@@ -5457,7 +5319,7 @@
               <a:buChar char="•"/>
             </a:pPr>
             <a:r>
-              <a:t>bypassPermissions: Skips all prompts (safe only)</a:t>
+              <a:t>bypassPermissions: Skips all prompts (safe environment only)</a:t>
             </a:r>
           </a:p>
           <a:p>
@@ -5493,7 +5355,7 @@
           <a:p>
             <a:fld id="{86CB4B4D-7CA3-9044-876B-883B54F8677D}" type="slidenum">
               <a:rPr lang="en-US" smtClean="0"/>
-              <a:t>25</a:t>
+              <a:t>2</a:t>
             </a:fld>
             <a:endParaRPr lang="en-US"/>
           </a:p>
@@ -5508,7 +5370,7 @@
 </file>
 
 <file path=ppt/slides/slide26.xml><?xml version="1.0" encoding="utf-8"?>
-<p:sld xmlns:a="http://schemas.openxmlformats.org/drawingml/2006/main" xmlns:r="http://schemas.openxmlformats.org/officeDocument/2006/relationships" xmlns:p="http://schemas.openxmlformats.org/presentationml/2006/main">
+<p:sld xmlns:a="http://schemas.openxmlformats.org/drawingml/2006/main" xmlns:p="http://schemas.openxmlformats.org/presentationml/2006/main" xmlns:r="http://schemas.openxmlformats.org/officeDocument/2006/relationships">
   <p:cSld>
     <p:spTree>
       <p:nvGrpSpPr>
@@ -5516,14 +5378,7 @@
         <p:cNvGrpSpPr/>
         <p:nvPr/>
       </p:nvGrpSpPr>
-      <p:grpSpPr>
-        <a:xfrm>
-          <a:off x="0" y="0"/>
-          <a:ext cx="0" cy="0"/>
-          <a:chOff x="0" y="0"/>
-          <a:chExt cx="0" cy="0"/>
-        </a:xfrm>
-      </p:grpSpPr>
+      <p:grpSpPr/>
       <p:sp>
         <p:nvSpPr>
           <p:cNvPr id="2" name="Title 1">
@@ -5549,8 +5404,8 @@
               <a:buNone/>
             </a:pPr>
             <a:r>
-              <a:rPr b="1"/>
-              <a:t>Granular Permission Rules</a:t>
+              <a:rPr b="1" sz="2400"/>
+              <a:t>Granular allow/deny/ask rules provide fine-grained control.</a:t>
             </a:r>
           </a:p>
         </p:txBody>
@@ -5644,7 +5499,7 @@
           <a:p>
             <a:fld id="{86CB4B4D-7CA3-9044-876B-883B54F8677D}" type="slidenum">
               <a:rPr lang="en-US" smtClean="0"/>
-              <a:t>26</a:t>
+              <a:t>2</a:t>
             </a:fld>
             <a:endParaRPr lang="en-US"/>
           </a:p>
@@ -5659,7 +5514,7 @@
 </file>
 
 <file path=ppt/slides/slide27.xml><?xml version="1.0" encoding="utf-8"?>
-<p:sld xmlns:a="http://schemas.openxmlformats.org/drawingml/2006/main" xmlns:r="http://schemas.openxmlformats.org/officeDocument/2006/relationships" xmlns:p="http://schemas.openxmlformats.org/presentationml/2006/main">
+<p:sld xmlns:a="http://schemas.openxmlformats.org/drawingml/2006/main" xmlns:p="http://schemas.openxmlformats.org/presentationml/2006/main" xmlns:r="http://schemas.openxmlformats.org/officeDocument/2006/relationships">
   <p:cSld>
     <p:spTree>
       <p:nvGrpSpPr>
@@ -5667,14 +5522,7 @@
         <p:cNvGrpSpPr/>
         <p:nvPr/>
       </p:nvGrpSpPr>
-      <p:grpSpPr>
-        <a:xfrm>
-          <a:off x="0" y="0"/>
-          <a:ext cx="0" cy="0"/>
-          <a:chOff x="0" y="0"/>
-          <a:chExt cx="0" cy="0"/>
-        </a:xfrm>
-      </p:grpSpPr>
+      <p:grpSpPr/>
       <p:sp>
         <p:nvSpPr>
           <p:cNvPr id="2" name="Title 1">
@@ -5700,8 +5548,8 @@
               <a:buNone/>
             </a:pPr>
             <a:r>
-              <a:rPr b="1"/>
-              <a:t>Hooks: Custom Tool Logic</a:t>
+              <a:rPr b="1" sz="2200"/>
+              <a:t>Hooks let you run custom scripts before and after tool execution.</a:t>
             </a:r>
           </a:p>
         </p:txBody>
@@ -5767,7 +5615,7 @@
               <a:buChar char="•"/>
             </a:pPr>
             <a:r>
-              <a:t>Can block, modify, or auto-approve</a:t>
+              <a:t>Can block, modify, or auto-approve based on custom logic</a:t>
             </a:r>
           </a:p>
         </p:txBody>
@@ -5795,7 +5643,7 @@
           <a:p>
             <a:fld id="{86CB4B4D-7CA3-9044-876B-883B54F8677D}" type="slidenum">
               <a:rPr lang="en-US" smtClean="0"/>
-              <a:t>27</a:t>
+              <a:t>2</a:t>
             </a:fld>
             <a:endParaRPr lang="en-US"/>
           </a:p>
@@ -5810,7 +5658,7 @@
 </file>
 
 <file path=ppt/slides/slide28.xml><?xml version="1.0" encoding="utf-8"?>
-<p:sld xmlns:a="http://schemas.openxmlformats.org/drawingml/2006/main" xmlns:r="http://schemas.openxmlformats.org/officeDocument/2006/relationships" xmlns:p="http://schemas.openxmlformats.org/presentationml/2006/main">
+<p:sld xmlns:a="http://schemas.openxmlformats.org/drawingml/2006/main" xmlns:p="http://schemas.openxmlformats.org/presentationml/2006/main" xmlns:r="http://schemas.openxmlformats.org/officeDocument/2006/relationships">
   <p:cSld>
     <p:spTree>
       <p:nvGrpSpPr>
@@ -5818,14 +5666,7 @@
         <p:cNvGrpSpPr/>
         <p:nvPr/>
       </p:nvGrpSpPr>
-      <p:grpSpPr>
-        <a:xfrm>
-          <a:off x="0" y="0"/>
-          <a:ext cx="0" cy="0"/>
-          <a:chOff x="0" y="0"/>
-          <a:chExt cx="0" cy="0"/>
-        </a:xfrm>
-      </p:grpSpPr>
+      <p:grpSpPr/>
       <p:sp>
         <p:nvSpPr>
           <p:cNvPr id="2" name="Title 1">
@@ -5851,8 +5692,8 @@
               <a:buNone/>
             </a:pPr>
             <a:r>
-              <a:rPr b="1"/>
-              <a:t>The "Lethal Trifecta" Security Risk</a:t>
+              <a:rPr b="1" sz="2200"/>
+              <a:t>The "Lethal Trifecta" identifies three data theft risk elements.</a:t>
             </a:r>
           </a:p>
         </p:txBody>
@@ -5902,7 +5743,7 @@
               <a:buChar char="•"/>
             </a:pPr>
             <a:r>
-              <a:t>2. Exposure to untrusted content (web, user input)</a:t>
+              <a:t>2. Exposure to untrusted content (web pages, user input)</a:t>
             </a:r>
           </a:p>
           <a:p>
@@ -5918,7 +5759,7 @@
               <a:buChar char="•"/>
             </a:pPr>
             <a:r>
-              <a:t>"Text into your LLM = control over tools"</a:t>
+              <a:t>"Text into your LLM = full control over what tools it runs"</a:t>
             </a:r>
           </a:p>
         </p:txBody>
@@ -5946,7 +5787,7 @@
           <a:p>
             <a:fld id="{86CB4B4D-7CA3-9044-876B-883B54F8677D}" type="slidenum">
               <a:rPr lang="en-US" smtClean="0"/>
-              <a:t>28</a:t>
+              <a:t>2</a:t>
             </a:fld>
             <a:endParaRPr lang="en-US"/>
           </a:p>
@@ -5961,7 +5802,7 @@
 </file>
 
 <file path=ppt/slides/slide29.xml><?xml version="1.0" encoding="utf-8"?>
-<p:sld xmlns:a="http://schemas.openxmlformats.org/drawingml/2006/main" xmlns:r="http://schemas.openxmlformats.org/officeDocument/2006/relationships" xmlns:p="http://schemas.openxmlformats.org/presentationml/2006/main">
+<p:sld xmlns:a="http://schemas.openxmlformats.org/drawingml/2006/main" xmlns:p="http://schemas.openxmlformats.org/presentationml/2006/main" xmlns:r="http://schemas.openxmlformats.org/officeDocument/2006/relationships">
   <p:cSld>
     <p:spTree>
       <p:nvGrpSpPr>
@@ -5969,14 +5810,7 @@
         <p:cNvGrpSpPr/>
         <p:nvPr/>
       </p:nvGrpSpPr>
-      <p:grpSpPr>
-        <a:xfrm>
-          <a:off x="0" y="0"/>
-          <a:ext cx="0" cy="0"/>
-          <a:chOff x="0" y="0"/>
-          <a:chExt cx="0" cy="0"/>
-        </a:xfrm>
-      </p:grpSpPr>
+      <p:grpSpPr/>
       <p:sp>
         <p:nvSpPr>
           <p:cNvPr id="2" name="Title 1">
@@ -6002,8 +5836,8 @@
               <a:buNone/>
             </a:pPr>
             <a:r>
-              <a:rPr b="1"/>
-              <a:t>Cursor vs Claude Code</a:t>
+              <a:rPr b="1" sz="2200"/>
+              <a:t>Cursor is an AI assistant; Claude Code is an autonomous agent.</a:t>
             </a:r>
           </a:p>
         </p:txBody>
@@ -6045,39 +5879,39 @@
               <a:buChar char="•"/>
             </a:pPr>
             <a:r>
-              <a:t>Paradigm: Enhanced IDE vs Autonomous Agent</a:t>
-            </a:r>
-          </a:p>
-          <a:p>
-            <a:pPr marL="365760" indent="-182880" algn="l">
-              <a:buChar char="•"/>
-            </a:pPr>
-            <a:r>
-              <a:t>Interface: GUI (VS Code fork) vs CLI</a:t>
-            </a:r>
-          </a:p>
-          <a:p>
-            <a:pPr marL="365760" indent="-182880" algn="l">
-              <a:buChar char="•"/>
-            </a:pPr>
-            <a:r>
-              <a:t>Model: User-selectable vs Claude (optimized)</a:t>
-            </a:r>
-          </a:p>
-          <a:p>
-            <a:pPr marL="365760" indent="-182880" algn="l">
-              <a:buChar char="•"/>
-            </a:pPr>
-            <a:r>
-              <a:t>Execution: User-initiated vs Autonomous</a:t>
-            </a:r>
-          </a:p>
-          <a:p>
-            <a:pPr marL="365760" indent="-182880" algn="l">
-              <a:buChar char="•"/>
-            </a:pPr>
-            <a:r>
-              <a:t>Context: IDE-provided vs Full filesystem + shell</a:t>
+              <a:t>Paradigm: Cursor = Enhanced IDE, Claude Code = Autonomous Agent</a:t>
+            </a:r>
+          </a:p>
+          <a:p>
+            <a:pPr marL="365760" indent="-182880" algn="l">
+              <a:buChar char="•"/>
+            </a:pPr>
+            <a:r>
+              <a:t>Interface: Cursor = GUI (VS Code fork), Claude Code = CLI</a:t>
+            </a:r>
+          </a:p>
+          <a:p>
+            <a:pPr marL="365760" indent="-182880" algn="l">
+              <a:buChar char="•"/>
+            </a:pPr>
+            <a:r>
+              <a:t>Model: Cursor = User-selectable, Claude Code = Claude (optimized)</a:t>
+            </a:r>
+          </a:p>
+          <a:p>
+            <a:pPr marL="365760" indent="-182880" algn="l">
+              <a:buChar char="•"/>
+            </a:pPr>
+            <a:r>
+              <a:t>Execution: Cursor = User-initiated, Claude Code = Autonomous</a:t>
+            </a:r>
+          </a:p>
+          <a:p>
+            <a:pPr marL="365760" indent="-182880" algn="l">
+              <a:buChar char="•"/>
+            </a:pPr>
+            <a:r>
+              <a:t>Context: Cursor = IDE-provided, Claude Code = Full filesystem + shell</a:t>
             </a:r>
           </a:p>
         </p:txBody>
@@ -6105,7 +5939,7 @@
           <a:p>
             <a:fld id="{86CB4B4D-7CA3-9044-876B-883B54F8677D}" type="slidenum">
               <a:rPr lang="en-US" smtClean="0"/>
-              <a:t>29</a:t>
+              <a:t>2</a:t>
             </a:fld>
             <a:endParaRPr lang="en-US"/>
           </a:p>
@@ -6120,7 +5954,7 @@
 </file>
 
 <file path=ppt/slides/slide3.xml><?xml version="1.0" encoding="utf-8"?>
-<p:sld xmlns:a="http://schemas.openxmlformats.org/drawingml/2006/main" xmlns:r="http://schemas.openxmlformats.org/officeDocument/2006/relationships" xmlns:p="http://schemas.openxmlformats.org/presentationml/2006/main">
+<p:sld xmlns:a="http://schemas.openxmlformats.org/drawingml/2006/main" xmlns:p="http://schemas.openxmlformats.org/presentationml/2006/main" xmlns:r="http://schemas.openxmlformats.org/officeDocument/2006/relationships">
   <p:cSld>
     <p:spTree>
       <p:nvGrpSpPr>
@@ -6128,14 +5962,7 @@
         <p:cNvGrpSpPr/>
         <p:nvPr/>
       </p:nvGrpSpPr>
-      <p:grpSpPr>
-        <a:xfrm>
-          <a:off x="0" y="0"/>
-          <a:ext cx="0" cy="0"/>
-          <a:chOff x="0" y="0"/>
-          <a:chExt cx="0" cy="0"/>
-        </a:xfrm>
-      </p:grpSpPr>
+      <p:grpSpPr/>
       <p:sp>
         <p:nvSpPr>
           <p:cNvPr id="2" name="Title 1">
@@ -6161,8 +5988,8 @@
               <a:buNone/>
             </a:pPr>
             <a:r>
-              <a:rPr b="1"/>
-              <a:t>Engineers Design Systems, Not Write Code</a:t>
+              <a:rPr b="1" sz="2400"/>
+              <a:t>Engineers now design systems, not write software.</a:t>
             </a:r>
           </a:p>
         </p:txBody>
@@ -6256,7 +6083,7 @@
           <a:p>
             <a:fld id="{86CB4B4D-7CA3-9044-876B-883B54F8677D}" type="slidenum">
               <a:rPr lang="en-US" smtClean="0"/>
-              <a:t>3</a:t>
+              <a:t>2</a:t>
             </a:fld>
             <a:endParaRPr lang="en-US"/>
           </a:p>
@@ -6271,7 +6098,7 @@
 </file>
 
 <file path=ppt/slides/slide30.xml><?xml version="1.0" encoding="utf-8"?>
-<p:sld xmlns:a="http://schemas.openxmlformats.org/drawingml/2006/main" xmlns:r="http://schemas.openxmlformats.org/officeDocument/2006/relationships" xmlns:p="http://schemas.openxmlformats.org/presentationml/2006/main">
+<p:sld xmlns:a="http://schemas.openxmlformats.org/drawingml/2006/main" xmlns:p="http://schemas.openxmlformats.org/presentationml/2006/main" xmlns:r="http://schemas.openxmlformats.org/officeDocument/2006/relationships">
   <p:cSld>
     <p:spTree>
       <p:nvGrpSpPr>
@@ -6279,14 +6106,7 @@
         <p:cNvGrpSpPr/>
         <p:nvPr/>
       </p:nvGrpSpPr>
-      <p:grpSpPr>
-        <a:xfrm>
-          <a:off x="0" y="0"/>
-          <a:ext cx="0" cy="0"/>
-          <a:chOff x="0" y="0"/>
-          <a:chExt cx="0" cy="0"/>
-        </a:xfrm>
-      </p:grpSpPr>
+      <p:grpSpPr/>
       <p:sp>
         <p:nvSpPr>
           <p:cNvPr id="2" name="Title 1">
@@ -6312,8 +6132,8 @@
               <a:buNone/>
             </a:pPr>
             <a:r>
-              <a:rPr b="1"/>
-              <a:t>When to Use Each Tool</a:t>
+              <a:rPr b="1" sz="2200"/>
+              <a:t>Think in files → use Cursor. Think in tasks → use Claude Code.</a:t>
             </a:r>
           </a:p>
         </p:txBody>
@@ -6355,23 +6175,23 @@
               <a:buChar char="•"/>
             </a:pPr>
             <a:r>
-              <a:t>Cursor: Quick inline edits, code explanation, GUI preference</a:t>
-            </a:r>
-          </a:p>
-          <a:p>
-            <a:pPr marL="365760" indent="-182880" algn="l">
-              <a:buChar char="•"/>
-            </a:pPr>
-            <a:r>
-              <a:t>Claude Code: Multi-file refactoring, autonomous completion</a:t>
-            </a:r>
-          </a:p>
-          <a:p>
-            <a:pPr marL="365760" indent="-182880" algn="l">
-              <a:buChar char="•"/>
-            </a:pPr>
-            <a:r>
-              <a:t>Claude Code: Pipeline automation, shell tasks</a:t>
+              <a:t>Cursor excels at: Quick inline edits, code explanation, GUI preference</a:t>
+            </a:r>
+          </a:p>
+          <a:p>
+            <a:pPr marL="365760" indent="-182880" algn="l">
+              <a:buChar char="•"/>
+            </a:pPr>
+            <a:r>
+              <a:t>Claude Code excels at: Multi-file refactoring, autonomous completion</a:t>
+            </a:r>
+          </a:p>
+          <a:p>
+            <a:pPr marL="365760" indent="-182880" algn="l">
+              <a:buChar char="•"/>
+            </a:pPr>
+            <a:r>
+              <a:t>Claude Code: Pipeline automation, tasks requiring shell access</a:t>
             </a:r>
           </a:p>
           <a:p>
@@ -6407,7 +6227,7 @@
           <a:p>
             <a:fld id="{86CB4B4D-7CA3-9044-876B-883B54F8677D}" type="slidenum">
               <a:rPr lang="en-US" smtClean="0"/>
-              <a:t>30</a:t>
+              <a:t>2</a:t>
             </a:fld>
             <a:endParaRPr lang="en-US"/>
           </a:p>
@@ -6422,7 +6242,7 @@
 </file>
 
 <file path=ppt/slides/slide31.xml><?xml version="1.0" encoding="utf-8"?>
-<p:sld xmlns:a="http://schemas.openxmlformats.org/drawingml/2006/main" xmlns:r="http://schemas.openxmlformats.org/officeDocument/2006/relationships" xmlns:p="http://schemas.openxmlformats.org/presentationml/2006/main">
+<p:sld xmlns:a="http://schemas.openxmlformats.org/drawingml/2006/main" xmlns:p="http://schemas.openxmlformats.org/presentationml/2006/main" xmlns:r="http://schemas.openxmlformats.org/officeDocument/2006/relationships">
   <p:cSld>
     <p:spTree>
       <p:nvGrpSpPr>
@@ -6430,14 +6250,7 @@
         <p:cNvGrpSpPr/>
         <p:nvPr/>
       </p:nvGrpSpPr>
-      <p:grpSpPr>
-        <a:xfrm>
-          <a:off x="0" y="0"/>
-          <a:ext cx="0" cy="0"/>
-          <a:chOff x="0" y="0"/>
-          <a:chExt cx="0" cy="0"/>
-        </a:xfrm>
-      </p:grpSpPr>
+      <p:grpSpPr/>
       <p:sp>
         <p:nvSpPr>
           <p:cNvPr id="2" name="Title 1">
@@ -6463,8 +6276,8 @@
               <a:buNone/>
             </a:pPr>
             <a:r>
-              <a:rPr b="1"/>
-              <a:t>Alternative Tools Comparison</a:t>
+              <a:rPr b="1" sz="2400"/>
+              <a:t>OpenCode, Aider, and Gemini CLI offer different trade-offs.</a:t>
             </a:r>
           </a:p>
         </p:txBody>
@@ -6514,15 +6327,15 @@
               <a:buChar char="•"/>
             </a:pPr>
             <a:r>
-              <a:t>Aider: Code graph, git — Monorepos, explicit control</a:t>
-            </a:r>
-          </a:p>
-          <a:p>
-            <a:pPr marL="365760" indent="-182880" algn="l">
-              <a:buChar char="•"/>
-            </a:pPr>
-            <a:r>
-              <a:t>Gemini CLI: 1M context, free tier — Google Cloud, docs</a:t>
+              <a:t>Aider: Code graph, git integration — Monorepos, explicit control</a:t>
+            </a:r>
+          </a:p>
+          <a:p>
+            <a:pPr marL="365760" indent="-182880" algn="l">
+              <a:buChar char="•"/>
+            </a:pPr>
+            <a:r>
+              <a:t>Gemini CLI: 1M context, free tier — Google Cloud, docs tasks</a:t>
             </a:r>
           </a:p>
           <a:p>
@@ -6558,7 +6371,7 @@
           <a:p>
             <a:fld id="{86CB4B4D-7CA3-9044-876B-883B54F8677D}" type="slidenum">
               <a:rPr lang="en-US" smtClean="0"/>
-              <a:t>31</a:t>
+              <a:t>2</a:t>
             </a:fld>
             <a:endParaRPr lang="en-US"/>
           </a:p>
@@ -6573,7 +6386,7 @@
 </file>
 
 <file path=ppt/slides/slide32.xml><?xml version="1.0" encoding="utf-8"?>
-<p:sld xmlns:a="http://schemas.openxmlformats.org/drawingml/2006/main" xmlns:r="http://schemas.openxmlformats.org/officeDocument/2006/relationships" xmlns:p="http://schemas.openxmlformats.org/presentationml/2006/main">
+<p:sld xmlns:a="http://schemas.openxmlformats.org/drawingml/2006/main" xmlns:p="http://schemas.openxmlformats.org/presentationml/2006/main" xmlns:r="http://schemas.openxmlformats.org/officeDocument/2006/relationships">
   <p:cSld>
     <p:spTree>
       <p:nvGrpSpPr>
@@ -6581,14 +6394,7 @@
         <p:cNvGrpSpPr/>
         <p:nvPr/>
       </p:nvGrpSpPr>
-      <p:grpSpPr>
-        <a:xfrm>
-          <a:off x="0" y="0"/>
-          <a:ext cx="0" cy="0"/>
-          <a:chOff x="0" y="0"/>
-          <a:chExt cx="0" cy="0"/>
-        </a:xfrm>
-      </p:grpSpPr>
+      <p:grpSpPr/>
       <p:sp>
         <p:nvSpPr>
           <p:cNvPr id="2" name="Title 1">
@@ -6614,8 +6420,8 @@
               <a:buNone/>
             </a:pPr>
             <a:r>
-              <a:rPr b="1"/>
-              <a:t>SWE-bench Performance</a:t>
+              <a:rPr b="1" sz="2400"/>
+              <a:t>Claude Code with Opus 4.5 leads SWE-bench at 80.9%.</a:t>
             </a:r>
           </a:p>
         </p:txBody>
@@ -6717,7 +6523,7 @@
           <a:p>
             <a:fld id="{86CB4B4D-7CA3-9044-876B-883B54F8677D}" type="slidenum">
               <a:rPr lang="en-US" smtClean="0"/>
-              <a:t>32</a:t>
+              <a:t>2</a:t>
             </a:fld>
             <a:endParaRPr lang="en-US"/>
           </a:p>
@@ -6732,7 +6538,7 @@
 </file>
 
 <file path=ppt/slides/slide33.xml><?xml version="1.0" encoding="utf-8"?>
-<p:sld xmlns:a="http://schemas.openxmlformats.org/drawingml/2006/main" xmlns:r="http://schemas.openxmlformats.org/officeDocument/2006/relationships" xmlns:p="http://schemas.openxmlformats.org/presentationml/2006/main">
+<p:sld xmlns:a="http://schemas.openxmlformats.org/drawingml/2006/main" xmlns:p="http://schemas.openxmlformats.org/presentationml/2006/main" xmlns:r="http://schemas.openxmlformats.org/officeDocument/2006/relationships">
   <p:cSld>
     <p:spTree>
       <p:nvGrpSpPr>
@@ -6740,14 +6546,7 @@
         <p:cNvGrpSpPr/>
         <p:nvPr/>
       </p:nvGrpSpPr>
-      <p:grpSpPr>
-        <a:xfrm>
-          <a:off x="0" y="0"/>
-          <a:ext cx="0" cy="0"/>
-          <a:chOff x="0" y="0"/>
-          <a:chExt cx="0" cy="0"/>
-        </a:xfrm>
-      </p:grpSpPr>
+      <p:grpSpPr/>
       <p:sp>
         <p:nvSpPr>
           <p:cNvPr id="2" name="Title 1">
@@ -6773,8 +6572,8 @@
               <a:buNone/>
             </a:pPr>
             <a:r>
-              <a:rPr b="1"/>
-              <a:t>This Presentation: The Workflow</a:t>
+              <a:rPr b="1" sz="2400"/>
+              <a:t>This presentation demonstrates the workflow we've described.</a:t>
             </a:r>
           </a:p>
         </p:txBody>
@@ -6816,11 +6615,11 @@
               <a:buChar char="•"/>
             </a:pPr>
             <a:r>
-              <a:t>CLAUDE.md → scratch/SCRATCH.md (raw notes)</a:t>
-            </a:r>
-          </a:p>
-          <a:p>
-            <a:pPr marL="731520" lvl="1" indent="-182880" algn="l">
+              <a:t>CLAUDE.md (instructions) → scratch/SCRATCH.md (raw notes)</a:t>
+            </a:r>
+          </a:p>
+          <a:p>
+            <a:pPr lvl="1" marL="731520" indent="-182880" algn="l">
               <a:buChar char="•"/>
             </a:pPr>
             <a:r>
@@ -6828,7 +6627,7 @@
             </a:r>
           </a:p>
           <a:p>
-            <a:pPr marL="731520" lvl="1" indent="-182880" algn="l">
+            <a:pPr lvl="1" marL="731520" indent="-182880" algn="l">
               <a:buChar char="•"/>
             </a:pPr>
             <a:r>
@@ -6836,7 +6635,7 @@
             </a:r>
           </a:p>
           <a:p>
-            <a:pPr marL="731520" lvl="1" indent="-182880" algn="l">
+            <a:pPr lvl="1" marL="731520" indent="-182880" algn="l">
               <a:buChar char="•"/>
             </a:pPr>
             <a:r>
@@ -6844,7 +6643,7 @@
             </a:r>
           </a:p>
           <a:p>
-            <a:pPr marL="731520" lvl="1" indent="-182880" algn="l">
+            <a:pPr lvl="1" marL="731520" indent="-182880" algn="l">
               <a:buChar char="•"/>
             </a:pPr>
             <a:r>
@@ -6876,7 +6675,7 @@
           <a:p>
             <a:fld id="{86CB4B4D-7CA3-9044-876B-883B54F8677D}" type="slidenum">
               <a:rPr lang="en-US" smtClean="0"/>
-              <a:t>33</a:t>
+              <a:t>2</a:t>
             </a:fld>
             <a:endParaRPr lang="en-US"/>
           </a:p>
@@ -6891,7 +6690,7 @@
 </file>
 
 <file path=ppt/slides/slide34.xml><?xml version="1.0" encoding="utf-8"?>
-<p:sld xmlns:a="http://schemas.openxmlformats.org/drawingml/2006/main" xmlns:r="http://schemas.openxmlformats.org/officeDocument/2006/relationships" xmlns:p="http://schemas.openxmlformats.org/presentationml/2006/main">
+<p:sld xmlns:a="http://schemas.openxmlformats.org/drawingml/2006/main" xmlns:p="http://schemas.openxmlformats.org/presentationml/2006/main" xmlns:r="http://schemas.openxmlformats.org/officeDocument/2006/relationships">
   <p:cSld>
     <p:spTree>
       <p:nvGrpSpPr>
@@ -6899,14 +6698,7 @@
         <p:cNvGrpSpPr/>
         <p:nvPr/>
       </p:nvGrpSpPr>
-      <p:grpSpPr>
-        <a:xfrm>
-          <a:off x="0" y="0"/>
-          <a:ext cx="0" cy="0"/>
-          <a:chOff x="0" y="0"/>
-          <a:chExt cx="0" cy="0"/>
-        </a:xfrm>
-      </p:grpSpPr>
+      <p:grpSpPr/>
       <p:sp>
         <p:nvSpPr>
           <p:cNvPr id="2" name="Title 1">
@@ -6932,8 +6724,8 @@
               <a:buNone/>
             </a:pPr>
             <a:r>
-              <a:rPr b="1"/>
-              <a:t>Git Commits Document Collaboration</a:t>
+              <a:rPr b="1" sz="2400"/>
+              <a:t>Each commit documents the human-agent collaboration.</a:t>
             </a:r>
           </a:p>
         </p:txBody>
@@ -7035,7 +6827,7 @@
           <a:p>
             <a:fld id="{86CB4B4D-7CA3-9044-876B-883B54F8677D}" type="slidenum">
               <a:rPr lang="en-US" smtClean="0"/>
-              <a:t>34</a:t>
+              <a:t>2</a:t>
             </a:fld>
             <a:endParaRPr lang="en-US"/>
           </a:p>
@@ -7050,7 +6842,7 @@
 </file>
 
 <file path=ppt/slides/slide35.xml><?xml version="1.0" encoding="utf-8"?>
-<p:sld xmlns:a="http://schemas.openxmlformats.org/drawingml/2006/main" xmlns:r="http://schemas.openxmlformats.org/officeDocument/2006/relationships" xmlns:p="http://schemas.openxmlformats.org/presentationml/2006/main">
+<p:sld xmlns:a="http://schemas.openxmlformats.org/drawingml/2006/main" xmlns:p="http://schemas.openxmlformats.org/presentationml/2006/main" xmlns:r="http://schemas.openxmlformats.org/officeDocument/2006/relationships">
   <p:cSld>
     <p:spTree>
       <p:nvGrpSpPr>
@@ -7058,14 +6850,7 @@
         <p:cNvGrpSpPr/>
         <p:nvPr/>
       </p:nvGrpSpPr>
-      <p:grpSpPr>
-        <a:xfrm>
-          <a:off x="0" y="0"/>
-          <a:ext cx="0" cy="0"/>
-          <a:chOff x="0" y="0"/>
-          <a:chExt cx="0" cy="0"/>
-        </a:xfrm>
-      </p:grpSpPr>
+      <p:grpSpPr/>
       <p:sp>
         <p:nvSpPr>
           <p:cNvPr id="2" name="Title 1">
@@ -7091,8 +6876,8 @@
               <a:buNone/>
             </a:pPr>
             <a:r>
-              <a:rPr b="1"/>
-              <a:t>[Live Demo] Practical Workflow</a:t>
+              <a:rPr b="1" sz="2400"/>
+              <a:t>[Live Demo] Claude Code workflow on a practical task.</a:t>
             </a:r>
           </a:p>
         </p:txBody>
@@ -7186,7 +6971,7 @@
           <a:p>
             <a:fld id="{86CB4B4D-7CA3-9044-876B-883B54F8677D}" type="slidenum">
               <a:rPr lang="en-US" smtClean="0"/>
-              <a:t>35</a:t>
+              <a:t>2</a:t>
             </a:fld>
             <a:endParaRPr lang="en-US"/>
           </a:p>
@@ -7201,7 +6986,7 @@
 </file>
 
 <file path=ppt/slides/slide36.xml><?xml version="1.0" encoding="utf-8"?>
-<p:sld xmlns:a="http://schemas.openxmlformats.org/drawingml/2006/main" xmlns:r="http://schemas.openxmlformats.org/officeDocument/2006/relationships" xmlns:p="http://schemas.openxmlformats.org/presentationml/2006/main">
+<p:sld xmlns:a="http://schemas.openxmlformats.org/drawingml/2006/main" xmlns:p="http://schemas.openxmlformats.org/presentationml/2006/main" xmlns:r="http://schemas.openxmlformats.org/officeDocument/2006/relationships">
   <p:cSld>
     <p:spTree>
       <p:nvGrpSpPr>
@@ -7209,14 +6994,7 @@
         <p:cNvGrpSpPr/>
         <p:nvPr/>
       </p:nvGrpSpPr>
-      <p:grpSpPr>
-        <a:xfrm>
-          <a:off x="0" y="0"/>
-          <a:ext cx="0" cy="0"/>
-          <a:chOff x="0" y="0"/>
-          <a:chExt cx="0" cy="0"/>
-        </a:xfrm>
-      </p:grpSpPr>
+      <p:grpSpPr/>
       <p:sp>
         <p:nvSpPr>
           <p:cNvPr id="2" name="Title 1">
@@ -7242,8 +7020,8 @@
               <a:buNone/>
             </a:pPr>
             <a:r>
-              <a:rPr b="1"/>
-              <a:t>Ralph-Wiggum: Iterative Loops</a:t>
+              <a:rPr b="1" sz="2400"/>
+              <a:t>Ralph-Wiggum: iterative loops that treat failure as data.</a:t>
             </a:r>
           </a:p>
         </p:txBody>
@@ -7285,31 +7063,31 @@
               <a:buChar char="•"/>
             </a:pPr>
             <a:r>
-              <a:t>"While loop that feeds AI agent a prompt until completion"</a:t>
-            </a:r>
-          </a:p>
-          <a:p>
-            <a:pPr marL="365760" indent="-182880" algn="l">
-              <a:buChar char="•"/>
-            </a:pPr>
-            <a:r>
-              <a:t>Deterministic stopping criteria</a:t>
-            </a:r>
-          </a:p>
-          <a:p>
-            <a:pPr marL="365760" indent="-182880" algn="l">
-              <a:buChar char="•"/>
-            </a:pPr>
-            <a:r>
-              <a:t>Failure-as-data: setbacks guide refinement</a:t>
-            </a:r>
-          </a:p>
-          <a:p>
-            <a:pPr marL="365760" indent="-182880" algn="l">
-              <a:buChar char="•"/>
-            </a:pPr>
-            <a:r>
-              <a:t>"LLMs are mirrors of operator skill"</a:t>
+              <a:t>"A while loop that feeds an AI agent a prompt until completion"</a:t>
+            </a:r>
+          </a:p>
+          <a:p>
+            <a:pPr marL="365760" indent="-182880" algn="l">
+              <a:buChar char="•"/>
+            </a:pPr>
+            <a:r>
+              <a:t>Deterministic stopping criteria (not "try once and fail")</a:t>
+            </a:r>
+          </a:p>
+          <a:p>
+            <a:pPr marL="365760" indent="-182880" algn="l">
+              <a:buChar char="•"/>
+            </a:pPr>
+            <a:r>
+              <a:t>Failure-as-data philosophy: setbacks guide refinement</a:t>
+            </a:r>
+          </a:p>
+          <a:p>
+            <a:pPr marL="365760" indent="-182880" algn="l">
+              <a:buChar char="•"/>
+            </a:pPr>
+            <a:r>
+              <a:t>Prompt-centric design: "LLMs are mirrors of operator skill"</a:t>
             </a:r>
           </a:p>
         </p:txBody>
@@ -7337,7 +7115,7 @@
           <a:p>
             <a:fld id="{86CB4B4D-7CA3-9044-876B-883B54F8677D}" type="slidenum">
               <a:rPr lang="en-US" smtClean="0"/>
-              <a:t>36</a:t>
+              <a:t>2</a:t>
             </a:fld>
             <a:endParaRPr lang="en-US"/>
           </a:p>
@@ -7352,7 +7130,7 @@
 </file>
 
 <file path=ppt/slides/slide37.xml><?xml version="1.0" encoding="utf-8"?>
-<p:sld xmlns:a="http://schemas.openxmlformats.org/drawingml/2006/main" xmlns:r="http://schemas.openxmlformats.org/officeDocument/2006/relationships" xmlns:p="http://schemas.openxmlformats.org/presentationml/2006/main">
+<p:sld xmlns:a="http://schemas.openxmlformats.org/drawingml/2006/main" xmlns:p="http://schemas.openxmlformats.org/presentationml/2006/main" xmlns:r="http://schemas.openxmlformats.org/officeDocument/2006/relationships">
   <p:cSld>
     <p:spTree>
       <p:nvGrpSpPr>
@@ -7360,14 +7138,7 @@
         <p:cNvGrpSpPr/>
         <p:nvPr/>
       </p:nvGrpSpPr>
-      <p:grpSpPr>
-        <a:xfrm>
-          <a:off x="0" y="0"/>
-          <a:ext cx="0" cy="0"/>
-          <a:chOff x="0" y="0"/>
-          <a:chExt cx="0" cy="0"/>
-        </a:xfrm>
-      </p:grpSpPr>
+      <p:grpSpPr/>
       <p:sp>
         <p:nvSpPr>
           <p:cNvPr id="2" name="Title 1">
@@ -7393,8 +7164,8 @@
               <a:buNone/>
             </a:pPr>
             <a:r>
-              <a:rPr b="1"/>
-              <a:t>Adoption Is the Challenge</a:t>
+              <a:rPr b="1" sz="2400"/>
+              <a:t>The future is here—adoption is the primary challenge.</a:t>
             </a:r>
           </a:p>
         </p:txBody>
@@ -7436,31 +7207,31 @@
               <a:buChar char="•"/>
             </a:pPr>
             <a:r>
-              <a:t>Old: Write code myself → New: Design workflows</a:t>
-            </a:r>
-          </a:p>
-          <a:p>
-            <a:pPr marL="365760" indent="-182880" algn="l">
-              <a:buChar char="•"/>
-            </a:pPr>
-            <a:r>
-              <a:t>Old: One-shot prompts → New: Iterative loops</a:t>
-            </a:r>
-          </a:p>
-          <a:p>
-            <a:pPr marL="365760" indent="-182880" algn="l">
-              <a:buChar char="•"/>
-            </a:pPr>
-            <a:r>
-              <a:t>Old: Static instructions → New: Improved artifacts</a:t>
-            </a:r>
-          </a:p>
-          <a:p>
-            <a:pPr marL="365760" indent="-182880" algn="l">
-              <a:buChar char="•"/>
-            </a:pPr>
-            <a:r>
-              <a:t>Old: Single session → New: Parallel agents</a:t>
+              <a:t>Old: Write code myself → New: Design workflows that write code</a:t>
+            </a:r>
+          </a:p>
+          <a:p>
+            <a:pPr marL="365760" indent="-182880" algn="l">
+              <a:buChar char="•"/>
+            </a:pPr>
+            <a:r>
+              <a:t>Old: One-shot prompts → New: Iterative loops until done</a:t>
+            </a:r>
+          </a:p>
+          <a:p>
+            <a:pPr marL="365760" indent="-182880" algn="l">
+              <a:buChar char="•"/>
+            </a:pPr>
+            <a:r>
+              <a:t>Old: Static instructions → New: Continuously improved artifacts</a:t>
+            </a:r>
+          </a:p>
+          <a:p>
+            <a:pPr marL="365760" indent="-182880" algn="l">
+              <a:buChar char="•"/>
+            </a:pPr>
+            <a:r>
+              <a:t>Old: Single session → New: Parallel agents on worktrees</a:t>
             </a:r>
           </a:p>
         </p:txBody>
@@ -7488,7 +7259,7 @@
           <a:p>
             <a:fld id="{86CB4B4D-7CA3-9044-876B-883B54F8677D}" type="slidenum">
               <a:rPr lang="en-US" smtClean="0"/>
-              <a:t>37</a:t>
+              <a:t>2</a:t>
             </a:fld>
             <a:endParaRPr lang="en-US"/>
           </a:p>
@@ -7503,7 +7274,7 @@
 </file>
 
 <file path=ppt/slides/slide38.xml><?xml version="1.0" encoding="utf-8"?>
-<p:sld xmlns:a="http://schemas.openxmlformats.org/drawingml/2006/main" xmlns:r="http://schemas.openxmlformats.org/officeDocument/2006/relationships" xmlns:p="http://schemas.openxmlformats.org/presentationml/2006/main">
+<p:sld xmlns:a="http://schemas.openxmlformats.org/drawingml/2006/main" xmlns:p="http://schemas.openxmlformats.org/presentationml/2006/main" xmlns:r="http://schemas.openxmlformats.org/officeDocument/2006/relationships">
   <p:cSld>
     <p:spTree>
       <p:nvGrpSpPr>
@@ -7511,14 +7282,7 @@
         <p:cNvGrpSpPr/>
         <p:nvPr/>
       </p:nvGrpSpPr>
-      <p:grpSpPr>
-        <a:xfrm>
-          <a:off x="0" y="0"/>
-          <a:ext cx="0" cy="0"/>
-          <a:chOff x="0" y="0"/>
-          <a:chExt cx="0" cy="0"/>
-        </a:xfrm>
-      </p:grpSpPr>
+      <p:grpSpPr/>
       <p:sp>
         <p:nvSpPr>
           <p:cNvPr id="2" name="Title 1">
@@ -7544,8 +7308,8 @@
               <a:buNone/>
             </a:pPr>
             <a:r>
-              <a:rPr b="1"/>
-              <a:t>Key Takeaways</a:t>
+              <a:rPr b="1" sz="2200"/>
+              <a:t>Compound efficiency through workflow, context, and parallelization.</a:t>
             </a:r>
           </a:p>
         </p:txBody>
@@ -7587,39 +7351,39 @@
               <a:buChar char="•"/>
             </a:pPr>
             <a:r>
-              <a:t>1. Claude Code = LLM + filesystem = general agent</a:t>
-            </a:r>
-          </a:p>
-          <a:p>
-            <a:pPr marL="365760" indent="-182880" algn="l">
-              <a:buChar char="•"/>
-            </a:pPr>
-            <a:r>
-              <a:t>2. Workflows compound with each CLAUDE.md update</a:t>
-            </a:r>
-          </a:p>
-          <a:p>
-            <a:pPr marL="365760" indent="-182880" algn="l">
-              <a:buChar char="•"/>
-            </a:pPr>
-            <a:r>
-              <a:t>3. Context engineering is fundamental</a:t>
-            </a:r>
-          </a:p>
-          <a:p>
-            <a:pPr marL="365760" indent="-182880" algn="l">
-              <a:buChar char="•"/>
-            </a:pPr>
-            <a:r>
-              <a:t>4. Git worktree enables parallelization</a:t>
-            </a:r>
-          </a:p>
-          <a:p>
-            <a:pPr marL="365760" indent="-182880" algn="l">
-              <a:buChar char="•"/>
-            </a:pPr>
-            <a:r>
-              <a:t>5. Future: iterative loops until completion</a:t>
+              <a:t>1. Claude Code = LLM + filesystem access = general agent</a:t>
+            </a:r>
+          </a:p>
+          <a:p>
+            <a:pPr marL="365760" indent="-182880" algn="l">
+              <a:buChar char="•"/>
+            </a:pPr>
+            <a:r>
+              <a:t>2. Workflows compound—every CLAUDE.md update improves the system</a:t>
+            </a:r>
+          </a:p>
+          <a:p>
+            <a:pPr marL="365760" indent="-182880" algn="l">
+              <a:buChar char="•"/>
+            </a:pPr>
+            <a:r>
+              <a:t>3. Context engineering is the fundamental skill</a:t>
+            </a:r>
+          </a:p>
+          <a:p>
+            <a:pPr marL="365760" indent="-182880" algn="l">
+              <a:buChar char="•"/>
+            </a:pPr>
+            <a:r>
+              <a:t>4. Parallelization via git worktree multiplies efficiency</a:t>
+            </a:r>
+          </a:p>
+          <a:p>
+            <a:pPr marL="365760" indent="-182880" algn="l">
+              <a:buChar char="•"/>
+            </a:pPr>
+            <a:r>
+              <a:t>5. The future is iterative loops that run until completion</a:t>
             </a:r>
           </a:p>
         </p:txBody>
@@ -7647,7 +7411,7 @@
           <a:p>
             <a:fld id="{86CB4B4D-7CA3-9044-876B-883B54F8677D}" type="slidenum">
               <a:rPr lang="en-US" smtClean="0"/>
-              <a:t>38</a:t>
+              <a:t>2</a:t>
             </a:fld>
             <a:endParaRPr lang="en-US"/>
           </a:p>
@@ -7662,7 +7426,7 @@
 </file>
 
 <file path=ppt/slides/slide39.xml><?xml version="1.0" encoding="utf-8"?>
-<p:sld xmlns:a="http://schemas.openxmlformats.org/drawingml/2006/main" xmlns:r="http://schemas.openxmlformats.org/officeDocument/2006/relationships" xmlns:p="http://schemas.openxmlformats.org/presentationml/2006/main">
+<p:sld xmlns:a="http://schemas.openxmlformats.org/drawingml/2006/main" xmlns:p="http://schemas.openxmlformats.org/presentationml/2006/main" xmlns:r="http://schemas.openxmlformats.org/officeDocument/2006/relationships">
   <p:cSld>
     <p:spTree>
       <p:nvGrpSpPr>
@@ -7670,14 +7434,7 @@
         <p:cNvGrpSpPr/>
         <p:nvPr/>
       </p:nvGrpSpPr>
-      <p:grpSpPr>
-        <a:xfrm>
-          <a:off x="0" y="0"/>
-          <a:ext cx="0" cy="0"/>
-          <a:chOff x="0" y="0"/>
-          <a:chExt cx="0" cy="0"/>
-        </a:xfrm>
-      </p:grpSpPr>
+      <p:grpSpPr/>
       <p:sp>
         <p:nvSpPr>
           <p:cNvPr id="2" name="Title 1">
@@ -7703,8 +7460,8 @@
               <a:buNone/>
             </a:pPr>
             <a:r>
-              <a:rPr b="1"/>
-              <a:t>Resources</a:t>
+              <a:rPr b="1" sz="2400"/>
+              <a:t>Resources for getting started with Claude Code.</a:t>
             </a:r>
           </a:p>
         </p:txBody>
@@ -7750,7 +7507,7 @@
             </a:r>
           </a:p>
           <a:p>
-            <a:pPr marL="731520" lvl="1" indent="-182880" algn="l">
+            <a:pPr lvl="1" marL="731520" indent="-182880" algn="l">
               <a:buChar char="•"/>
             </a:pPr>
             <a:r>
@@ -7766,7 +7523,7 @@
             </a:r>
           </a:p>
           <a:p>
-            <a:pPr marL="731520" lvl="1" indent="-182880" algn="l">
+            <a:pPr lvl="1" marL="731520" indent="-182880" algn="l">
               <a:buChar char="•"/>
             </a:pPr>
             <a:r>
@@ -7798,7 +7555,7 @@
           <a:p>
             <a:fld id="{86CB4B4D-7CA3-9044-876B-883B54F8677D}" type="slidenum">
               <a:rPr lang="en-US" smtClean="0"/>
-              <a:t>39</a:t>
+              <a:t>2</a:t>
             </a:fld>
             <a:endParaRPr lang="en-US"/>
           </a:p>
@@ -7813,7 +7570,7 @@
 </file>
 
 <file path=ppt/slides/slide4.xml><?xml version="1.0" encoding="utf-8"?>
-<p:sld xmlns:a="http://schemas.openxmlformats.org/drawingml/2006/main" xmlns:r="http://schemas.openxmlformats.org/officeDocument/2006/relationships" xmlns:p="http://schemas.openxmlformats.org/presentationml/2006/main">
+<p:sld xmlns:a="http://schemas.openxmlformats.org/drawingml/2006/main" xmlns:p="http://schemas.openxmlformats.org/presentationml/2006/main" xmlns:r="http://schemas.openxmlformats.org/officeDocument/2006/relationships">
   <p:cSld>
     <p:spTree>
       <p:nvGrpSpPr>
@@ -7821,14 +7578,7 @@
         <p:cNvGrpSpPr/>
         <p:nvPr/>
       </p:nvGrpSpPr>
-      <p:grpSpPr>
-        <a:xfrm>
-          <a:off x="0" y="0"/>
-          <a:ext cx="0" cy="0"/>
-          <a:chOff x="0" y="0"/>
-          <a:chExt cx="0" cy="0"/>
-        </a:xfrm>
-      </p:grpSpPr>
+      <p:grpSpPr/>
       <p:sp>
         <p:nvSpPr>
           <p:cNvPr id="2" name="Title 1">
@@ -7854,8 +7604,8 @@
               <a:buNone/>
             </a:pPr>
             <a:r>
-              <a:rPr b="1"/>
-              <a:t>Communicate Intent, Not Implementation</a:t>
+              <a:rPr b="1" sz="2200"/>
+              <a:t>Communicate intent structurally—let agents find the implementation.</a:t>
             </a:r>
           </a:p>
         </p:txBody>
@@ -7921,7 +7671,7 @@
               <a:buChar char="•"/>
             </a:pPr>
             <a:r>
-              <a:t>"It's like I was driving a race car in first gear."</a:t>
+              <a:t>"It's like I was driving a race car in first gear the whole time."</a:t>
             </a:r>
           </a:p>
         </p:txBody>
@@ -7949,7 +7699,7 @@
           <a:p>
             <a:fld id="{86CB4B4D-7CA3-9044-876B-883B54F8677D}" type="slidenum">
               <a:rPr lang="en-US" smtClean="0"/>
-              <a:t>4</a:t>
+              <a:t>2</a:t>
             </a:fld>
             <a:endParaRPr lang="en-US"/>
           </a:p>
@@ -7964,7 +7714,7 @@
 </file>
 
 <file path=ppt/slides/slide40.xml><?xml version="1.0" encoding="utf-8"?>
-<p:sld xmlns:a="http://schemas.openxmlformats.org/drawingml/2006/main" xmlns:r="http://schemas.openxmlformats.org/officeDocument/2006/relationships" xmlns:p="http://schemas.openxmlformats.org/presentationml/2006/main">
+<p:sld xmlns:a="http://schemas.openxmlformats.org/drawingml/2006/main" xmlns:p="http://schemas.openxmlformats.org/presentationml/2006/main" xmlns:r="http://schemas.openxmlformats.org/officeDocument/2006/relationships">
   <p:cSld>
     <p:spTree>
       <p:nvGrpSpPr>
@@ -7972,14 +7722,7 @@
         <p:cNvGrpSpPr/>
         <p:nvPr/>
       </p:nvGrpSpPr>
-      <p:grpSpPr>
-        <a:xfrm>
-          <a:off x="0" y="0"/>
-          <a:ext cx="0" cy="0"/>
-          <a:chOff x="0" y="0"/>
-          <a:chExt cx="0" cy="0"/>
-        </a:xfrm>
-      </p:grpSpPr>
+      <p:grpSpPr/>
       <p:sp>
         <p:nvSpPr>
           <p:cNvPr id="2" name="Title 1">
@@ -8005,7 +7748,7 @@
               <a:buNone/>
             </a:pPr>
             <a:r>
-              <a:rPr b="1"/>
+              <a:rPr b="1" sz="2800"/>
               <a:t>Questions?</a:t>
             </a:r>
           </a:p>
@@ -8056,7 +7799,7 @@
               <a:buChar char="•"/>
             </a:pPr>
             <a:r>
-              <a:t>What tasks benefit most from agent automation?</a:t>
+              <a:t>What tasks would benefit most from agent automation?</a:t>
             </a:r>
           </a:p>
           <a:p>
@@ -8100,7 +7843,7 @@
           <a:p>
             <a:fld id="{86CB4B4D-7CA3-9044-876B-883B54F8677D}" type="slidenum">
               <a:rPr lang="en-US" smtClean="0"/>
-              <a:t>40</a:t>
+              <a:t>2</a:t>
             </a:fld>
             <a:endParaRPr lang="en-US"/>
           </a:p>
@@ -8115,7 +7858,7 @@
 </file>
 
 <file path=ppt/slides/slide41.xml><?xml version="1.0" encoding="utf-8"?>
-<p:sld xmlns:a="http://schemas.openxmlformats.org/drawingml/2006/main" xmlns:r="http://schemas.openxmlformats.org/officeDocument/2006/relationships" xmlns:p="http://schemas.openxmlformats.org/presentationml/2006/main">
+<p:sld xmlns:a="http://schemas.openxmlformats.org/drawingml/2006/main" xmlns:p="http://schemas.openxmlformats.org/presentationml/2006/main" xmlns:r="http://schemas.openxmlformats.org/officeDocument/2006/relationships">
   <p:cSld>
     <p:spTree>
       <p:nvGrpSpPr>
@@ -8123,14 +7866,7 @@
         <p:cNvGrpSpPr/>
         <p:nvPr/>
       </p:nvGrpSpPr>
-      <p:grpSpPr>
-        <a:xfrm>
-          <a:off x="0" y="0"/>
-          <a:ext cx="0" cy="0"/>
-          <a:chOff x="0" y="0"/>
-          <a:chExt cx="0" cy="0"/>
-        </a:xfrm>
-      </p:grpSpPr>
+      <p:grpSpPr/>
       <p:sp>
         <p:nvSpPr>
           <p:cNvPr id="2" name="Title 1">
@@ -8156,8 +7892,8 @@
               <a:buNone/>
             </a:pPr>
             <a:r>
-              <a:rPr b="1"/>
-              <a:t>Appendix: Four Core Tools</a:t>
+              <a:rPr b="1" sz="2200"/>
+              <a:t>Claude Code uses only four core tools: Read, Write, Edit, Bash.</a:t>
             </a:r>
           </a:p>
         </p:txBody>
@@ -8231,7 +7967,7 @@
               <a:buChar char="•"/>
             </a:pPr>
             <a:r>
-              <a:t>"Four tools outperform complex ecosystems" — Zechner</a:t>
+              <a:t>"Four tools outperform complex tool ecosystems" — Mario Zechner</a:t>
             </a:r>
           </a:p>
         </p:txBody>
@@ -8259,7 +7995,7 @@
           <a:p>
             <a:fld id="{86CB4B4D-7CA3-9044-876B-883B54F8677D}" type="slidenum">
               <a:rPr lang="en-US" smtClean="0"/>
-              <a:t>41</a:t>
+              <a:t>2</a:t>
             </a:fld>
             <a:endParaRPr lang="en-US"/>
           </a:p>
@@ -8274,7 +8010,7 @@
 </file>
 
 <file path=ppt/slides/slide42.xml><?xml version="1.0" encoding="utf-8"?>
-<p:sld xmlns:a="http://schemas.openxmlformats.org/drawingml/2006/main" xmlns:r="http://schemas.openxmlformats.org/officeDocument/2006/relationships" xmlns:p="http://schemas.openxmlformats.org/presentationml/2006/main">
+<p:sld xmlns:a="http://schemas.openxmlformats.org/drawingml/2006/main" xmlns:p="http://schemas.openxmlformats.org/presentationml/2006/main" xmlns:r="http://schemas.openxmlformats.org/officeDocument/2006/relationships">
   <p:cSld>
     <p:spTree>
       <p:nvGrpSpPr>
@@ -8282,14 +8018,7 @@
         <p:cNvGrpSpPr/>
         <p:nvPr/>
       </p:nvGrpSpPr>
-      <p:grpSpPr>
-        <a:xfrm>
-          <a:off x="0" y="0"/>
-          <a:ext cx="0" cy="0"/>
-          <a:chOff x="0" y="0"/>
-          <a:chExt cx="0" cy="0"/>
-        </a:xfrm>
-      </p:grpSpPr>
+      <p:grpSpPr/>
       <p:sp>
         <p:nvSpPr>
           <p:cNvPr id="2" name="Title 1">
@@ -8315,8 +8044,8 @@
               <a:buNone/>
             </a:pPr>
             <a:r>
-              <a:rPr b="1"/>
-              <a:t>Appendix: MCP Server Setup</a:t>
+              <a:rPr b="1" sz="2200"/>
+              <a:t>MCP servers extend Claude Code with external tool capabilities.</a:t>
             </a:r>
           </a:p>
         </p:txBody>
@@ -8382,7 +8111,7 @@
               <a:buChar char="•"/>
             </a:pPr>
             <a:r>
-              <a:t>Trade-off: Convenience vs context overhead</a:t>
+              <a:t>Trade-off: Convenience vs. context window overhead</a:t>
             </a:r>
           </a:p>
         </p:txBody>
@@ -8410,7 +8139,7 @@
           <a:p>
             <a:fld id="{86CB4B4D-7CA3-9044-876B-883B54F8677D}" type="slidenum">
               <a:rPr lang="en-US" smtClean="0"/>
-              <a:t>42</a:t>
+              <a:t>2</a:t>
             </a:fld>
             <a:endParaRPr lang="en-US"/>
           </a:p>
@@ -8425,7 +8154,7 @@
 </file>
 
 <file path=ppt/slides/slide43.xml><?xml version="1.0" encoding="utf-8"?>
-<p:sld xmlns:a="http://schemas.openxmlformats.org/drawingml/2006/main" xmlns:r="http://schemas.openxmlformats.org/officeDocument/2006/relationships" xmlns:p="http://schemas.openxmlformats.org/presentationml/2006/main">
+<p:sld xmlns:a="http://schemas.openxmlformats.org/drawingml/2006/main" xmlns:p="http://schemas.openxmlformats.org/presentationml/2006/main" xmlns:r="http://schemas.openxmlformats.org/officeDocument/2006/relationships">
   <p:cSld>
     <p:spTree>
       <p:nvGrpSpPr>
@@ -8433,14 +8162,7 @@
         <p:cNvGrpSpPr/>
         <p:nvPr/>
       </p:nvGrpSpPr>
-      <p:grpSpPr>
-        <a:xfrm>
-          <a:off x="0" y="0"/>
-          <a:ext cx="0" cy="0"/>
-          <a:chOff x="0" y="0"/>
-          <a:chExt cx="0" cy="0"/>
-        </a:xfrm>
-      </p:grpSpPr>
+      <p:grpSpPr/>
       <p:sp>
         <p:nvSpPr>
           <p:cNvPr id="2" name="Title 1">
@@ -8466,8 +8188,8 @@
               <a:buNone/>
             </a:pPr>
             <a:r>
-              <a:rPr b="1"/>
-              <a:t>Appendix: Gemini CLI</a:t>
+              <a:rPr b="1" sz="2200"/>
+              <a:t>Gemini CLI provides 1M token context and a generous free tier.</a:t>
             </a:r>
           </a:p>
         </p:txBody>
@@ -8541,7 +8263,7 @@
               <a:buChar char="•"/>
             </a:pPr>
             <a:r>
-              <a:t>Best for: Google Cloud, documentation, exploration</a:t>
+              <a:t>Best for: Google Cloud users, documentation, exploration</a:t>
             </a:r>
           </a:p>
         </p:txBody>
@@ -8569,7 +8291,7 @@
           <a:p>
             <a:fld id="{86CB4B4D-7CA3-9044-876B-883B54F8677D}" type="slidenum">
               <a:rPr lang="en-US" smtClean="0"/>
-              <a:t>43</a:t>
+              <a:t>2</a:t>
             </a:fld>
             <a:endParaRPr lang="en-US"/>
           </a:p>
@@ -8584,7 +8306,7 @@
 </file>
 
 <file path=ppt/slides/slide5.xml><?xml version="1.0" encoding="utf-8"?>
-<p:sld xmlns:a="http://schemas.openxmlformats.org/drawingml/2006/main" xmlns:r="http://schemas.openxmlformats.org/officeDocument/2006/relationships" xmlns:p="http://schemas.openxmlformats.org/presentationml/2006/main">
+<p:sld xmlns:a="http://schemas.openxmlformats.org/drawingml/2006/main" xmlns:p="http://schemas.openxmlformats.org/presentationml/2006/main" xmlns:r="http://schemas.openxmlformats.org/officeDocument/2006/relationships">
   <p:cSld>
     <p:spTree>
       <p:nvGrpSpPr>
@@ -8592,14 +8314,7 @@
         <p:cNvGrpSpPr/>
         <p:nvPr/>
       </p:nvGrpSpPr>
-      <p:grpSpPr>
-        <a:xfrm>
-          <a:off x="0" y="0"/>
-          <a:ext cx="0" cy="0"/>
-          <a:chOff x="0" y="0"/>
-          <a:chExt cx="0" cy="0"/>
-        </a:xfrm>
-      </p:grpSpPr>
+      <p:grpSpPr/>
       <p:sp>
         <p:nvSpPr>
           <p:cNvPr id="2" name="Title 1">
@@ -8625,8 +8340,8 @@
               <a:buNone/>
             </a:pPr>
             <a:r>
-              <a:rPr b="1"/>
-              <a:t>Compound Efficiency Through Updates</a:t>
+              <a:rPr b="1" sz="2400"/>
+              <a:t>Every CLAUDE.md update compounds your efficiency gains.</a:t>
             </a:r>
           </a:p>
         </p:txBody>
@@ -8672,7 +8387,7 @@
             </a:r>
           </a:p>
           <a:p>
-            <a:pPr marL="731520" lvl="1" indent="-182880" algn="l">
+            <a:pPr lvl="1" marL="731520" indent="-182880" algn="l">
               <a:buChar char="•"/>
             </a:pPr>
             <a:r>
@@ -8680,7 +8395,7 @@
             </a:r>
           </a:p>
           <a:p>
-            <a:pPr marL="731520" lvl="1" indent="-182880" algn="l">
+            <a:pPr lvl="1" marL="731520" indent="-182880" algn="l">
               <a:buChar char="•"/>
             </a:pPr>
             <a:r>
@@ -8688,7 +8403,7 @@
             </a:r>
           </a:p>
           <a:p>
-            <a:pPr marL="731520" lvl="1" indent="-182880" algn="l">
+            <a:pPr lvl="1" marL="731520" indent="-182880" algn="l">
               <a:buChar char="•"/>
             </a:pPr>
             <a:r>
@@ -8720,7 +8435,7 @@
           <a:p>
             <a:fld id="{86CB4B4D-7CA3-9044-876B-883B54F8677D}" type="slidenum">
               <a:rPr lang="en-US" smtClean="0"/>
-              <a:t>5</a:t>
+              <a:t>2</a:t>
             </a:fld>
             <a:endParaRPr lang="en-US"/>
           </a:p>
@@ -8735,7 +8450,7 @@
 </file>
 
 <file path=ppt/slides/slide6.xml><?xml version="1.0" encoding="utf-8"?>
-<p:sld xmlns:a="http://schemas.openxmlformats.org/drawingml/2006/main" xmlns:r="http://schemas.openxmlformats.org/officeDocument/2006/relationships" xmlns:p="http://schemas.openxmlformats.org/presentationml/2006/main">
+<p:sld xmlns:a="http://schemas.openxmlformats.org/drawingml/2006/main" xmlns:p="http://schemas.openxmlformats.org/presentationml/2006/main" xmlns:r="http://schemas.openxmlformats.org/officeDocument/2006/relationships">
   <p:cSld>
     <p:spTree>
       <p:nvGrpSpPr>
@@ -8743,14 +8458,7 @@
         <p:cNvGrpSpPr/>
         <p:nvPr/>
       </p:nvGrpSpPr>
-      <p:grpSpPr>
-        <a:xfrm>
-          <a:off x="0" y="0"/>
-          <a:ext cx="0" cy="0"/>
-          <a:chOff x="0" y="0"/>
-          <a:chExt cx="0" cy="0"/>
-        </a:xfrm>
-      </p:grpSpPr>
+      <p:grpSpPr/>
       <p:sp>
         <p:nvSpPr>
           <p:cNvPr id="2" name="Title 1">
@@ -8776,8 +8484,8 @@
               <a:buNone/>
             </a:pPr>
             <a:r>
-              <a:rPr b="1"/>
-              <a:t>Claude Code: A General Agent Timeline</a:t>
+              <a:rPr b="1" sz="2400"/>
+              <a:t>Claude Code is a general agent, not just a coding tool.</a:t>
             </a:r>
           </a:p>
         </p:txBody>
@@ -8871,7 +8579,7 @@
           <a:p>
             <a:fld id="{86CB4B4D-7CA3-9044-876B-883B54F8677D}" type="slidenum">
               <a:rPr lang="en-US" smtClean="0"/>
-              <a:t>6</a:t>
+              <a:t>2</a:t>
             </a:fld>
             <a:endParaRPr lang="en-US"/>
           </a:p>
@@ -8886,7 +8594,7 @@
 </file>
 
 <file path=ppt/slides/slide7.xml><?xml version="1.0" encoding="utf-8"?>
-<p:sld xmlns:a="http://schemas.openxmlformats.org/drawingml/2006/main" xmlns:r="http://schemas.openxmlformats.org/officeDocument/2006/relationships" xmlns:p="http://schemas.openxmlformats.org/presentationml/2006/main">
+<p:sld xmlns:a="http://schemas.openxmlformats.org/drawingml/2006/main" xmlns:p="http://schemas.openxmlformats.org/presentationml/2006/main" xmlns:r="http://schemas.openxmlformats.org/officeDocument/2006/relationships">
   <p:cSld>
     <p:spTree>
       <p:nvGrpSpPr>
@@ -8894,14 +8602,7 @@
         <p:cNvGrpSpPr/>
         <p:nvPr/>
       </p:nvGrpSpPr>
-      <p:grpSpPr>
-        <a:xfrm>
-          <a:off x="0" y="0"/>
-          <a:ext cx="0" cy="0"/>
-          <a:chOff x="0" y="0"/>
-          <a:chExt cx="0" cy="0"/>
-        </a:xfrm>
-      </p:grpSpPr>
+      <p:grpSpPr/>
       <p:sp>
         <p:nvSpPr>
           <p:cNvPr id="2" name="Title 1">
@@ -8927,8 +8628,8 @@
               <a:buNone/>
             </a:pPr>
             <a:r>
-              <a:rPr b="1"/>
-              <a:t>Automate Anything You Can Type</a:t>
+              <a:rPr b="1" sz="2400"/>
+              <a:t>Claude Code automates anything you can type into a computer.</a:t>
             </a:r>
           </a:p>
         </p:txBody>
@@ -9030,7 +8731,7 @@
           <a:p>
             <a:fld id="{86CB4B4D-7CA3-9044-876B-883B54F8677D}" type="slidenum">
               <a:rPr lang="en-US" smtClean="0"/>
-              <a:t>7</a:t>
+              <a:t>2</a:t>
             </a:fld>
             <a:endParaRPr lang="en-US"/>
           </a:p>
@@ -9045,7 +8746,7 @@
 </file>
 
 <file path=ppt/slides/slide8.xml><?xml version="1.0" encoding="utf-8"?>
-<p:sld xmlns:a="http://schemas.openxmlformats.org/drawingml/2006/main" xmlns:r="http://schemas.openxmlformats.org/officeDocument/2006/relationships" xmlns:p="http://schemas.openxmlformats.org/presentationml/2006/main">
+<p:sld xmlns:a="http://schemas.openxmlformats.org/drawingml/2006/main" xmlns:p="http://schemas.openxmlformats.org/presentationml/2006/main" xmlns:r="http://schemas.openxmlformats.org/officeDocument/2006/relationships">
   <p:cSld>
     <p:spTree>
       <p:nvGrpSpPr>
@@ -9053,14 +8754,7 @@
         <p:cNvGrpSpPr/>
         <p:nvPr/>
       </p:nvGrpSpPr>
-      <p:grpSpPr>
-        <a:xfrm>
-          <a:off x="0" y="0"/>
-          <a:ext cx="0" cy="0"/>
-          <a:chOff x="0" y="0"/>
-          <a:chExt cx="0" cy="0"/>
-        </a:xfrm>
-      </p:grpSpPr>
+      <p:grpSpPr/>
       <p:sp>
         <p:nvSpPr>
           <p:cNvPr id="2" name="Title 1">
@@ -9086,8 +8780,8 @@
               <a:buNone/>
             </a:pPr>
             <a:r>
-              <a:rPr b="1"/>
-              <a:t>LLM + File System Access = Agent</a:t>
+              <a:rPr b="1" sz="2200"/>
+              <a:t>Claude Code is an LLM with permission to access a file system.</a:t>
             </a:r>
           </a:p>
         </p:txBody>
@@ -9129,39 +8823,31 @@
               <a:buChar char="•"/>
             </a:pPr>
             <a:r>
-              <a:t>Web Chatbot: Stateless, copy-paste snippets</a:t>
-            </a:r>
-          </a:p>
-          <a:p>
-            <a:pPr marL="365760" indent="-182880" algn="l">
-              <a:buChar char="•"/>
-            </a:pPr>
-            <a:r>
-              <a:t>Claude Code: Persistent filesystem, direct file read/write</a:t>
-            </a:r>
-          </a:p>
-          <a:p>
-            <a:pPr marL="365760" indent="-182880" algn="l">
-              <a:buChar char="•"/>
-            </a:pPr>
-            <a:r>
-              <a:t>Web Chatbot: Human describes and executes</a:t>
-            </a:r>
-          </a:p>
-          <a:p>
-            <a:pPr marL="365760" indent="-182880" algn="l">
-              <a:buChar char="•"/>
-            </a:pPr>
-            <a:r>
-              <a:t>Claude Code: Agent explores and executes</a:t>
-            </a:r>
-          </a:p>
-          <a:p>
-            <a:pPr marL="365760" indent="-182880" algn="l">
-              <a:buChar char="•"/>
-            </a:pPr>
-            <a:r>
-              <a:t>"An LLM with permission to access a file system" — Willison</a:t>
+              <a:t>Web Chatbot: Stateless conversations, copy-paste snippets</a:t>
+            </a:r>
+          </a:p>
+          <a:p>
+            <a:pPr marL="365760" indent="-182880" algn="l">
+              <a:buChar char="•"/>
+            </a:pPr>
+            <a:r>
+              <a:t>Claude Code: Persistent filesystem access, direct file read/write</a:t>
+            </a:r>
+          </a:p>
+          <a:p>
+            <a:pPr marL="365760" indent="-182880" algn="l">
+              <a:buChar char="•"/>
+            </a:pPr>
+            <a:r>
+              <a:t>Web Chatbot: Describe your environment, human executes commands</a:t>
+            </a:r>
+          </a:p>
+          <a:p>
+            <a:pPr marL="365760" indent="-182880" algn="l">
+              <a:buChar char="•"/>
+            </a:pPr>
+            <a:r>
+              <a:t>Claude Code: Agent explores and executes autonomously</a:t>
             </a:r>
           </a:p>
         </p:txBody>
@@ -9189,7 +8875,7 @@
           <a:p>
             <a:fld id="{86CB4B4D-7CA3-9044-876B-883B54F8677D}" type="slidenum">
               <a:rPr lang="en-US" smtClean="0"/>
-              <a:t>8</a:t>
+              <a:t>2</a:t>
             </a:fld>
             <a:endParaRPr lang="en-US"/>
           </a:p>
@@ -9204,7 +8890,7 @@
 </file>
 
 <file path=ppt/slides/slide9.xml><?xml version="1.0" encoding="utf-8"?>
-<p:sld xmlns:a="http://schemas.openxmlformats.org/drawingml/2006/main" xmlns:r="http://schemas.openxmlformats.org/officeDocument/2006/relationships" xmlns:p="http://schemas.openxmlformats.org/presentationml/2006/main">
+<p:sld xmlns:a="http://schemas.openxmlformats.org/drawingml/2006/main" xmlns:p="http://schemas.openxmlformats.org/presentationml/2006/main" xmlns:r="http://schemas.openxmlformats.org/officeDocument/2006/relationships">
   <p:cSld>
     <p:spTree>
       <p:nvGrpSpPr>
@@ -9212,14 +8898,7 @@
         <p:cNvGrpSpPr/>
         <p:nvPr/>
       </p:nvGrpSpPr>
-      <p:grpSpPr>
-        <a:xfrm>
-          <a:off x="0" y="0"/>
-          <a:ext cx="0" cy="0"/>
-          <a:chOff x="0" y="0"/>
-          <a:chExt cx="0" cy="0"/>
-        </a:xfrm>
-      </p:grpSpPr>
+      <p:grpSpPr/>
       <p:sp>
         <p:nvSpPr>
           <p:cNvPr id="2" name="Title 1">
@@ -9245,8 +8924,8 @@
               <a:buNone/>
             </a:pPr>
             <a:r>
-              <a:rPr b="1"/>
-              <a:t>Simplicity Is the Feature</a:t>
+              <a:rPr b="1" sz="2400"/>
+              <a:t>Claude Code's power comes from its simplicity.</a:t>
             </a:r>
           </a:p>
         </p:txBody>
@@ -9312,7 +8991,7 @@
               <a:buChar char="•"/>
             </a:pPr>
             <a:r>
-              <a:t>Outsources hard parts to the LLM harness and environment</a:t>
+              <a:t>Outsources hard parts to the LLM harness and computer environment</a:t>
             </a:r>
           </a:p>
         </p:txBody>
@@ -9340,7 +9019,7 @@
           <a:p>
             <a:fld id="{86CB4B4D-7CA3-9044-876B-883B54F8677D}" type="slidenum">
               <a:rPr lang="en-US" smtClean="0"/>
-              <a:t>9</a:t>
+              <a:t>2</a:t>
             </a:fld>
             <a:endParaRPr lang="en-US"/>
           </a:p>
@@ -11908,26 +11587,6 @@
 </file>
 
 <file path=customXml/item1.xml><?xml version="1.0" encoding="utf-8"?>
-<?mso-contentType ?>
-<FormTemplates xmlns="http://schemas.microsoft.com/sharepoint/v3/contenttype/forms">
-  <Display>DocumentLibraryForm</Display>
-  <Edit>DocumentLibraryForm</Edit>
-  <New>DocumentLibraryForm</New>
-</FormTemplates>
-</file>
-
-<file path=customXml/item2.xml><?xml version="1.0" encoding="utf-8"?>
-<p:properties xmlns:p="http://schemas.microsoft.com/office/2006/metadata/properties" xmlns:xsi="http://www.w3.org/2001/XMLSchema-instance" xmlns:pc="http://schemas.microsoft.com/office/infopath/2007/PartnerControls">
-  <documentManagement>
-    <lcf76f155ced4ddcb4097134ff3c332f xmlns="baa02956-e5b0-401a-adb6-d3ab856a8db1">
-      <Terms xmlns="http://schemas.microsoft.com/office/infopath/2007/PartnerControls"/>
-    </lcf76f155ced4ddcb4097134ff3c332f>
-    <TaxCatchAll xmlns="758526ea-ff42-49f4-966e-8b92dfb8c37c" xsi:nil="true"/>
-  </documentManagement>
-</p:properties>
-</file>
-
-<file path=customXml/item3.xml><?xml version="1.0" encoding="utf-8"?>
 <ct:contentTypeSchema xmlns:ct="http://schemas.microsoft.com/office/2006/metadata/contentType" xmlns:ma="http://schemas.microsoft.com/office/2006/metadata/properties/metaAttributes" ct:_="" ma:_="" ma:contentTypeName="Document" ma:contentTypeID="0x010100C8D000A7A8EA4549909635EE44265AE2" ma:contentTypeVersion="12" ma:contentTypeDescription="Create a new document." ma:contentTypeScope="" ma:versionID="7f357fbe57b84af1bdddcd22c912bac7">
   <xsd:schema xmlns:xsd="http://www.w3.org/2001/XMLSchema" xmlns:xs="http://www.w3.org/2001/XMLSchema" xmlns:p="http://schemas.microsoft.com/office/2006/metadata/properties" xmlns:ns2="baa02956-e5b0-401a-adb6-d3ab856a8db1" xmlns:ns3="758526ea-ff42-49f4-966e-8b92dfb8c37c" targetNamespace="http://schemas.microsoft.com/office/2006/metadata/properties" ma:root="true" ma:fieldsID="f01aca49933565aaf8490f47588de525" ns2:_="" ns3:_="">
     <xsd:import namespace="baa02956-e5b0-401a-adb6-d3ab856a8db1"/>
@@ -12128,32 +11787,27 @@
 </ct:contentTypeSchema>
 </file>
 
-<file path=customXml/itemProps1.xml><?xml version="1.0" encoding="utf-8"?>
-<ds:datastoreItem xmlns:ds="http://schemas.openxmlformats.org/officeDocument/2006/customXml" ds:itemID="{F04B941D-E84F-47C8-84C7-8C66135B4CA1}">
-  <ds:schemaRefs>
-    <ds:schemaRef ds:uri="http://schemas.microsoft.com/sharepoint/v3/contenttype/forms"/>
-  </ds:schemaRefs>
-</ds:datastoreItem>
+<file path=customXml/item2.xml><?xml version="1.0" encoding="utf-8"?>
+<?mso-contentType ?>
+<FormTemplates xmlns="http://schemas.microsoft.com/sharepoint/v3/contenttype/forms">
+  <Display>DocumentLibraryForm</Display>
+  <Edit>DocumentLibraryForm</Edit>
+  <New>DocumentLibraryForm</New>
+</FormTemplates>
 </file>
 
-<file path=customXml/itemProps2.xml><?xml version="1.0" encoding="utf-8"?>
-<ds:datastoreItem xmlns:ds="http://schemas.openxmlformats.org/officeDocument/2006/customXml" ds:itemID="{B517E194-3F2D-4BC4-9EAF-A0569BAF4335}">
-  <ds:schemaRefs>
-    <ds:schemaRef ds:uri="baa02956-e5b0-401a-adb6-d3ab856a8db1"/>
-    <ds:schemaRef ds:uri="http://purl.org/dc/elements/1.1/"/>
-    <ds:schemaRef ds:uri="http://schemas.openxmlformats.org/package/2006/metadata/core-properties"/>
-    <ds:schemaRef ds:uri="http://schemas.microsoft.com/office/2006/documentManagement/types"/>
-    <ds:schemaRef ds:uri="758526ea-ff42-49f4-966e-8b92dfb8c37c"/>
-    <ds:schemaRef ds:uri="http://purl.org/dc/terms/"/>
-    <ds:schemaRef ds:uri="http://www.w3.org/XML/1998/namespace"/>
-    <ds:schemaRef ds:uri="http://schemas.microsoft.com/office/2006/metadata/properties"/>
-    <ds:schemaRef ds:uri="http://schemas.microsoft.com/office/infopath/2007/PartnerControls"/>
-    <ds:schemaRef ds:uri="http://purl.org/dc/dcmitype/"/>
-  </ds:schemaRefs>
-</ds:datastoreItem>
+<file path=customXml/item3.xml><?xml version="1.0" encoding="utf-8"?>
+<p:properties xmlns:p="http://schemas.microsoft.com/office/2006/metadata/properties" xmlns:xsi="http://www.w3.org/2001/XMLSchema-instance" xmlns:pc="http://schemas.microsoft.com/office/infopath/2007/PartnerControls">
+  <documentManagement>
+    <lcf76f155ced4ddcb4097134ff3c332f xmlns="baa02956-e5b0-401a-adb6-d3ab856a8db1">
+      <Terms xmlns="http://schemas.microsoft.com/office/infopath/2007/PartnerControls"/>
+    </lcf76f155ced4ddcb4097134ff3c332f>
+    <TaxCatchAll xmlns="758526ea-ff42-49f4-966e-8b92dfb8c37c" xsi:nil="true"/>
+  </documentManagement>
+</p:properties>
 </file>
 
-<file path=customXml/itemProps3.xml><?xml version="1.0" encoding="utf-8"?>
+<file path=customXml/itemProps1.xml><?xml version="1.0" encoding="utf-8"?>
 <ds:datastoreItem xmlns:ds="http://schemas.openxmlformats.org/officeDocument/2006/customXml" ds:itemID="{0A62184A-FEE7-42AA-86BE-4760650221E9}">
   <ds:schemaRefs>
     <ds:schemaRef ds:uri="758526ea-ff42-49f4-966e-8b92dfb8c37c"/>
@@ -12170,4 +11824,29 @@
     <ds:schemaRef ds:uri="http://www.w3.org/2001/XMLSchema"/>
   </ds:schemaRefs>
 </ds:datastoreItem>
+</file>
+
+<file path=customXml/itemProps2.xml><?xml version="1.0" encoding="utf-8"?>
+<ds:datastoreItem xmlns:ds="http://schemas.openxmlformats.org/officeDocument/2006/customXml" ds:itemID="{F04B941D-E84F-47C8-84C7-8C66135B4CA1}">
+  <ds:schemaRefs>
+    <ds:schemaRef ds:uri="http://schemas.microsoft.com/sharepoint/v3/contenttype/forms"/>
+  </ds:schemaRefs>
+</ds:datastoreItem>
+</file>
+
+<file path=customXml/itemProps3.xml><?xml version="1.0" encoding="utf-8"?>
+<ds:datastoreItem xmlns:ds="http://schemas.openxmlformats.org/officeDocument/2006/customXml" ds:itemID="{B517E194-3F2D-4BC4-9EAF-A0569BAF4335}">
+  <ds:schemaRefs>
+    <ds:schemaRef ds:uri="baa02956-e5b0-401a-adb6-d3ab856a8db1"/>
+    <ds:schemaRef ds:uri="http://purl.org/dc/elements/1.1/"/>
+    <ds:schemaRef ds:uri="http://schemas.openxmlformats.org/package/2006/metadata/core-properties"/>
+    <ds:schemaRef ds:uri="http://schemas.microsoft.com/office/2006/documentManagement/types"/>
+    <ds:schemaRef ds:uri="758526ea-ff42-49f4-966e-8b92dfb8c37c"/>
+    <ds:schemaRef ds:uri="http://purl.org/dc/terms/"/>
+    <ds:schemaRef ds:uri="http://www.w3.org/XML/1998/namespace"/>
+    <ds:schemaRef ds:uri="http://schemas.microsoft.com/office/2006/metadata/properties"/>
+    <ds:schemaRef ds:uri="http://schemas.microsoft.com/office/infopath/2007/PartnerControls"/>
+    <ds:schemaRef ds:uri="http://purl.org/dc/dcmitype/"/>
+  </ds:schemaRefs>
+</ds:datastoreItem>
 </file>
</xml_diff>